<commit_message>
docs: recreate study tracker slides based on requested 8-page structure
</commit_message>
<xml_diff>
--- a/study_tracker_presentation.pptx
+++ b/study_tracker_presentation.pptx
@@ -3091,7 +3091,7 @@
     <p:bg>
       <p:bgPr>
         <a:solidFill>
-          <a:srgbClr val="212121"/>
+          <a:srgbClr val="1E1E1E"/>
         </a:solidFill>
         <a:effectLst/>
       </p:bgPr>
@@ -3111,8 +3111,8 @@
         </p:nvSpPr>
         <p:spPr>
           <a:xfrm>
-            <a:off x="914400" y="2011680"/>
-            <a:ext cx="10332720" cy="2743200"/>
+            <a:off x="731520" y="2011680"/>
+            <a:ext cx="10698480" cy="3200400"/>
           </a:xfrm>
           <a:prstGeom prst="rect">
             <a:avLst/>
@@ -3125,8 +3125,8 @@
           </a:bodyPr>
           <a:lstStyle/>
           <a:p>
-            <a:pPr algn="l">
-              <a:defRPr sz="6400" b="1">
+            <a:pPr>
+              <a:defRPr sz="5400" b="1">
                 <a:solidFill>
                   <a:srgbClr val="FFD54F"/>
                 </a:solidFill>
@@ -3134,39 +3134,39 @@
               </a:defRPr>
             </a:pPr>
             <a:r>
-              <a:t>STUDY TRACKER</a:t>
-            </a:r>
-          </a:p>
-          <a:p>
-            <a:pPr algn="l">
+              <a:t>STUDY TRACKER FOR STUDENTS</a:t>
+            </a:r>
+          </a:p>
+          <a:p>
+            <a:pPr>
               <a:spcBef>
-                <a:spcPts val="1200"/>
+                <a:spcPts val="800"/>
               </a:spcBef>
-              <a:defRPr sz="2200">
-                <a:solidFill>
-                  <a:srgbClr val="FFFFFF"/>
-                </a:solidFill>
-                <a:latin typeface="Calibri"/>
-              </a:defRPr>
-            </a:pPr>
-            <a:r>
-              <a:t>Core System Logics, Adaptive Algorithms &amp; Interactive Features</a:t>
-            </a:r>
-          </a:p>
-          <a:p>
-            <a:pPr algn="l">
+              <a:defRPr sz="2000">
+                <a:solidFill>
+                  <a:srgbClr val="FFFFFF"/>
+                </a:solidFill>
+                <a:latin typeface="Calibri"/>
+              </a:defRPr>
+            </a:pPr>
+            <a:r>
+              <a:t>Problem Statement, Database Schemas, Data Flows &amp; Adaptive Scheduling Logics</a:t>
+            </a:r>
+          </a:p>
+          <a:p>
+            <a:pPr>
               <a:spcBef>
-                <a:spcPts val="3600"/>
+                <a:spcPts val="4800"/>
               </a:spcBef>
               <a:defRPr sz="1400">
                 <a:solidFill>
-                  <a:srgbClr val="AAAAAA"/>
-                </a:solidFill>
-                <a:latin typeface="Calibri"/>
-              </a:defRPr>
-            </a:pPr>
-            <a:r>
-              <a:t>Technical Presentation | Study Tracker App System</a:t>
+                  <a:srgbClr val="B4B4B4"/>
+                </a:solidFill>
+                <a:latin typeface="Calibri"/>
+              </a:defRPr>
+            </a:pPr>
+            <a:r>
+              <a:t>Designed for Self-Paced Video Courseware Organization &amp; Goal Tracking</a:t>
             </a:r>
           </a:p>
         </p:txBody>
@@ -3185,7 +3185,7 @@
     <p:bg>
       <p:bgPr>
         <a:solidFill>
-          <a:srgbClr val="212121"/>
+          <a:srgbClr val="1E1E1E"/>
         </a:solidFill>
         <a:effectLst/>
       </p:bgPr>
@@ -3205,8 +3205,8 @@
         </p:nvSpPr>
         <p:spPr>
           <a:xfrm>
-            <a:off x="731520" y="548640"/>
-            <a:ext cx="10698480" cy="914400"/>
+            <a:off x="731520" y="365760"/>
+            <a:ext cx="10698480" cy="365760"/>
           </a:xfrm>
           <a:prstGeom prst="rect">
             <a:avLst/>
@@ -3214,21 +3214,21 @@
           <a:noFill/>
         </p:spPr>
         <p:txBody>
-          <a:bodyPr wrap="square">
+          <a:bodyPr wrap="none">
             <a:spAutoFit/>
           </a:bodyPr>
           <a:lstStyle/>
           <a:p>
             <a:pPr>
-              <a:defRPr sz="3600" b="1">
-                <a:solidFill>
-                  <a:srgbClr val="FFD54F"/>
-                </a:solidFill>
-                <a:latin typeface="Calibri"/>
-              </a:defRPr>
-            </a:pPr>
-            <a:r>
-              <a:t>1. Core Architecture &amp; Tech Stack</a:t>
+              <a:defRPr sz="1100" b="1">
+                <a:solidFill>
+                  <a:srgbClr val="F48FB1"/>
+                </a:solidFill>
+                <a:latin typeface="Calibri"/>
+              </a:defRPr>
+            </a:pPr>
+            <a:r>
+              <a:t>INTRODUCTION</a:t>
             </a:r>
           </a:p>
         </p:txBody>
@@ -3241,8 +3241,8 @@
         </p:nvSpPr>
         <p:spPr>
           <a:xfrm>
-            <a:off x="731520" y="1645920"/>
-            <a:ext cx="10698480" cy="4572000"/>
+            <a:off x="731520" y="548640"/>
+            <a:ext cx="10698480" cy="731520"/>
           </a:xfrm>
           <a:prstGeom prst="rect">
             <a:avLst/>
@@ -3250,109 +3250,265 @@
           <a:noFill/>
         </p:spPr>
         <p:txBody>
-          <a:bodyPr wrap="square">
+          <a:bodyPr wrap="none">
             <a:spAutoFit/>
           </a:bodyPr>
           <a:lstStyle/>
-          <a:p/>
-          <a:p>
-            <a:pPr>
-              <a:spcAft>
-                <a:spcPts val="2000"/>
-              </a:spcAft>
-              <a:defRPr sz="1800" b="1">
-                <a:solidFill>
-                  <a:srgbClr val="4FC3F7"/>
-                </a:solidFill>
-                <a:latin typeface="Calibri"/>
-              </a:defRPr>
-            </a:pPr>
-            <a:r>
-              <a:t>• Backend Services (FastAPI + SQLAlchemy): </a:t>
-            </a:r>
-            <a:r>
-              <a:rPr sz="1600" b="0">
-                <a:solidFill>
-                  <a:srgbClr val="FFFFFF"/>
-                </a:solidFill>
-                <a:latin typeface="Calibri"/>
-              </a:rPr>
-              <a:t>Asynchronous, high-performance API endpoints serving plans, progress chart snapshots, daily goals, and YouTube operations.</a:t>
-            </a:r>
-          </a:p>
-          <a:p>
-            <a:pPr>
-              <a:spcAft>
-                <a:spcPts val="2000"/>
-              </a:spcAft>
-              <a:defRPr sz="1800" b="1">
-                <a:solidFill>
-                  <a:srgbClr val="4FC3F7"/>
-                </a:solidFill>
-                <a:latin typeface="Calibri"/>
-              </a:defRPr>
-            </a:pPr>
-            <a:r>
-              <a:t>• Frontend Application (React + Recharts): </a:t>
-            </a:r>
-            <a:r>
-              <a:rPr sz="1600" b="0">
-                <a:solidFill>
-                  <a:srgbClr val="FFFFFF"/>
-                </a:solidFill>
-                <a:latin typeface="Calibri"/>
-              </a:rPr>
-              <a:t>A highly interactive, zero-reload single page interface with dynamic state caching and a custom hand-drawn sketch layout.</a:t>
-            </a:r>
-          </a:p>
-          <a:p>
-            <a:pPr>
-              <a:spcAft>
-                <a:spcPts val="2000"/>
-              </a:spcAft>
-              <a:defRPr sz="1800" b="1">
-                <a:solidFill>
-                  <a:srgbClr val="4FC3F7"/>
-                </a:solidFill>
-                <a:latin typeface="Calibri"/>
-              </a:defRPr>
-            </a:pPr>
-            <a:r>
-              <a:t>• Database Engine (MySQL): </a:t>
-            </a:r>
-            <a:r>
-              <a:rPr sz="1600" b="0">
-                <a:solidFill>
-                  <a:srgbClr val="FFFFFF"/>
-                </a:solidFill>
-                <a:latin typeface="Calibri"/>
-              </a:rPr>
-              <a:t>Persistent relational schema tracking course enrollment, individual video completion states, progress snapshots, and calendar days.</a:t>
-            </a:r>
-          </a:p>
-          <a:p>
-            <a:pPr>
-              <a:spcAft>
-                <a:spcPts val="2000"/>
-              </a:spcAft>
-              <a:defRPr sz="1800" b="1">
-                <a:solidFill>
-                  <a:srgbClr val="4FC3F7"/>
-                </a:solidFill>
-                <a:latin typeface="Calibri"/>
-              </a:defRPr>
-            </a:pPr>
-            <a:r>
-              <a:t>• AI Operations (Google Gemini API): </a:t>
-            </a:r>
-            <a:r>
-              <a:rPr sz="1600" b="0">
-                <a:solidFill>
-                  <a:srgbClr val="FFFFFF"/>
-                </a:solidFill>
-                <a:latin typeface="Calibri"/>
-              </a:rPr>
-              <a:t>Leverages standard `gemini-1.5-flash` model for contextual chat tutoring, automated note taking, and practice Q&amp;As based on course transcripts.</a:t>
+          <a:p>
+            <a:pPr>
+              <a:defRPr sz="3200" b="1">
+                <a:solidFill>
+                  <a:srgbClr val="FFD54F"/>
+                </a:solidFill>
+                <a:latin typeface="Calibri"/>
+              </a:defRPr>
+            </a:pPr>
+            <a:r>
+              <a:t>Problem Statement, Solution &amp; Student Benefits</a:t>
+            </a:r>
+          </a:p>
+        </p:txBody>
+      </p:sp>
+      <p:sp>
+        <p:nvSpPr>
+          <p:cNvPr id="4" name="Rounded Rectangle 3"/>
+          <p:cNvSpPr/>
+          <p:nvPr/>
+        </p:nvSpPr>
+        <p:spPr>
+          <a:xfrm>
+            <a:off x="731520" y="1645920"/>
+            <a:ext cx="5120640" cy="4389120"/>
+          </a:xfrm>
+          <a:prstGeom prst="roundRect">
+            <a:avLst/>
+          </a:prstGeom>
+          <a:solidFill>
+            <a:srgbClr val="2D2D2D"/>
+          </a:solidFill>
+          <a:ln w="19050">
+            <a:solidFill>
+              <a:srgbClr val="505050"/>
+            </a:solidFill>
+          </a:ln>
+        </p:spPr>
+        <p:style>
+          <a:lnRef idx="1">
+            <a:schemeClr val="accent1"/>
+          </a:lnRef>
+          <a:fillRef idx="3">
+            <a:schemeClr val="accent1"/>
+          </a:fillRef>
+          <a:effectRef idx="2">
+            <a:schemeClr val="accent1"/>
+          </a:effectRef>
+          <a:fontRef idx="minor">
+            <a:schemeClr val="lt1"/>
+          </a:fontRef>
+        </p:style>
+        <p:txBody>
+          <a:bodyPr rtlCol="0" anchor="ctr" wrap="square" lIns="137160" tIns="137160" rIns="137160" bIns="137160"/>
+          <a:lstStyle/>
+          <a:p>
+            <a:pPr algn="ctr">
+              <a:spcAft>
+                <a:spcPts val="800"/>
+              </a:spcAft>
+              <a:defRPr sz="1600" b="1">
+                <a:solidFill>
+                  <a:srgbClr val="F48FB1"/>
+                </a:solidFill>
+                <a:latin typeface="Calibri"/>
+              </a:defRPr>
+            </a:pPr>
+            <a:r>
+              <a:t>⚠️ The Student's Problem</a:t>
+            </a:r>
+          </a:p>
+          <a:p>
+            <a:pPr>
+              <a:spcAft>
+                <a:spcPts val="400"/>
+              </a:spcAft>
+              <a:defRPr sz="1300">
+                <a:solidFill>
+                  <a:srgbClr val="FFFFFF"/>
+                </a:solidFill>
+                <a:latin typeface="Calibri"/>
+              </a:defRPr>
+            </a:pPr>
+            <a:r>
+              <a:t>• Video Courseware Disorganization: YouTube playlists and tutorials are scattered. Students lose track of which video they watched next.</a:t>
+            </a:r>
+          </a:p>
+          <a:p>
+            <a:pPr>
+              <a:spcAft>
+                <a:spcPts val="400"/>
+              </a:spcAft>
+              <a:defRPr sz="1300">
+                <a:solidFill>
+                  <a:srgbClr val="FFFFFF"/>
+                </a:solidFill>
+                <a:latin typeface="Calibri"/>
+              </a:defRPr>
+            </a:pPr>
+            <a:r>
+              <a:t>• Scheduling Overhead: Students waste time calculating when they will finish a course. If they miss one day, their study spreadsheet breaks.</a:t>
+            </a:r>
+          </a:p>
+          <a:p>
+            <a:pPr>
+              <a:spcAft>
+                <a:spcPts val="400"/>
+              </a:spcAft>
+              <a:defRPr sz="1300">
+                <a:solidFill>
+                  <a:srgbClr val="FFFFFF"/>
+                </a:solidFill>
+                <a:latin typeface="Calibri"/>
+              </a:defRPr>
+            </a:pPr>
+            <a:r>
+              <a:t>• Progress Deception: Counting videos completed gives a false sense of progress because videos have wildly different durations.</a:t>
+            </a:r>
+          </a:p>
+          <a:p>
+            <a:pPr>
+              <a:spcAft>
+                <a:spcPts val="400"/>
+              </a:spcAft>
+              <a:defRPr sz="1300">
+                <a:solidFill>
+                  <a:srgbClr val="FFFFFF"/>
+                </a:solidFill>
+                <a:latin typeface="Calibri"/>
+              </a:defRPr>
+            </a:pPr>
+            <a:r>
+              <a:t>• Stress &amp; Guilt: Falling behind creates an accumulated backlog of past tasks that induces anxiety and causes students to abandon plans.</a:t>
+            </a:r>
+          </a:p>
+        </p:txBody>
+      </p:sp>
+      <p:sp>
+        <p:nvSpPr>
+          <p:cNvPr id="5" name="Rounded Rectangle 4"/>
+          <p:cNvSpPr/>
+          <p:nvPr/>
+        </p:nvSpPr>
+        <p:spPr>
+          <a:xfrm>
+            <a:off x="6217920" y="1645920"/>
+            <a:ext cx="5120640" cy="4389120"/>
+          </a:xfrm>
+          <a:prstGeom prst="roundRect">
+            <a:avLst/>
+          </a:prstGeom>
+          <a:solidFill>
+            <a:srgbClr val="2D2D2D"/>
+          </a:solidFill>
+          <a:ln w="19050">
+            <a:solidFill>
+              <a:srgbClr val="505050"/>
+            </a:solidFill>
+          </a:ln>
+        </p:spPr>
+        <p:style>
+          <a:lnRef idx="1">
+            <a:schemeClr val="accent1"/>
+          </a:lnRef>
+          <a:fillRef idx="3">
+            <a:schemeClr val="accent1"/>
+          </a:fillRef>
+          <a:effectRef idx="2">
+            <a:schemeClr val="accent1"/>
+          </a:effectRef>
+          <a:fontRef idx="minor">
+            <a:schemeClr val="lt1"/>
+          </a:fontRef>
+        </p:style>
+        <p:txBody>
+          <a:bodyPr rtlCol="0" anchor="ctr" wrap="square" lIns="137160" tIns="137160" rIns="137160" bIns="137160"/>
+          <a:lstStyle/>
+          <a:p>
+            <a:pPr algn="ctr">
+              <a:spcAft>
+                <a:spcPts val="800"/>
+              </a:spcAft>
+              <a:defRPr sz="1600" b="1">
+                <a:solidFill>
+                  <a:srgbClr val="A5D6A7"/>
+                </a:solidFill>
+                <a:latin typeface="Calibri"/>
+              </a:defRPr>
+            </a:pPr>
+            <a:r>
+              <a:t>🚀 The Study Tracker Solution</a:t>
+            </a:r>
+          </a:p>
+          <a:p>
+            <a:pPr>
+              <a:spcAft>
+                <a:spcPts val="400"/>
+              </a:spcAft>
+              <a:defRPr sz="1300">
+                <a:solidFill>
+                  <a:srgbClr val="FFFFFF"/>
+                </a:solidFill>
+                <a:latin typeface="Calibri"/>
+              </a:defRPr>
+            </a:pPr>
+            <a:r>
+              <a:t>• Structured Playlist Ingestion: Consolidates all links, single videos, and playlists into one focused study workspace.</a:t>
+            </a:r>
+          </a:p>
+          <a:p>
+            <a:pPr>
+              <a:spcAft>
+                <a:spcPts val="400"/>
+              </a:spcAft>
+              <a:defRPr sz="1300">
+                <a:solidFill>
+                  <a:srgbClr val="FFFFFF"/>
+                </a:solidFill>
+                <a:latin typeface="Calibri"/>
+              </a:defRPr>
+            </a:pPr>
+            <a:r>
+              <a:t>• Automated Daily Scheduling: Converts massive course hours into realistic, bite-sized study blocks based on student availability.</a:t>
+            </a:r>
+          </a:p>
+          <a:p>
+            <a:pPr>
+              <a:spcAft>
+                <a:spcPts val="400"/>
+              </a:spcAft>
+              <a:defRPr sz="1300">
+                <a:solidFill>
+                  <a:srgbClr val="FFFFFF"/>
+                </a:solidFill>
+                <a:latin typeface="Calibri"/>
+              </a:defRPr>
+            </a:pPr>
+            <a:r>
+              <a:t>• Adaptive Re-planning: Dynamic schedule adjustments slide completed tasks to the past and reschedule remaining tasks starting today.</a:t>
+            </a:r>
+          </a:p>
+          <a:p>
+            <a:pPr>
+              <a:spcAft>
+                <a:spcPts val="400"/>
+              </a:spcAft>
+              <a:defRPr sz="1300">
+                <a:solidFill>
+                  <a:srgbClr val="FFFFFF"/>
+                </a:solidFill>
+                <a:latin typeface="Calibri"/>
+              </a:defRPr>
+            </a:pPr>
+            <a:r>
+              <a:t>• Double-Metric Estimation: Tracks progress based on both time duration watched and percentage of items completed.</a:t>
             </a:r>
           </a:p>
         </p:txBody>
@@ -3371,7 +3527,7 @@
     <p:bg>
       <p:bgPr>
         <a:solidFill>
-          <a:srgbClr val="212121"/>
+          <a:srgbClr val="1E1E1E"/>
         </a:solidFill>
         <a:effectLst/>
       </p:bgPr>
@@ -3391,8 +3547,8 @@
         </p:nvSpPr>
         <p:spPr>
           <a:xfrm>
-            <a:off x="731520" y="548640"/>
-            <a:ext cx="10698480" cy="914400"/>
+            <a:off x="731520" y="365760"/>
+            <a:ext cx="10698480" cy="365760"/>
           </a:xfrm>
           <a:prstGeom prst="rect">
             <a:avLst/>
@@ -3400,21 +3556,21 @@
           <a:noFill/>
         </p:spPr>
         <p:txBody>
-          <a:bodyPr wrap="square">
+          <a:bodyPr wrap="none">
             <a:spAutoFit/>
           </a:bodyPr>
           <a:lstStyle/>
           <a:p>
             <a:pPr>
-              <a:defRPr sz="3600" b="1">
-                <a:solidFill>
-                  <a:srgbClr val="FFD54F"/>
-                </a:solidFill>
-                <a:latin typeface="Calibri"/>
-              </a:defRPr>
-            </a:pPr>
-            <a:r>
-              <a:t>2. Flexible YouTube Importing &amp; Metadata Parsing</a:t>
+              <a:defRPr sz="1100" b="1">
+                <a:solidFill>
+                  <a:srgbClr val="F48FB1"/>
+                </a:solidFill>
+                <a:latin typeface="Calibri"/>
+              </a:defRPr>
+            </a:pPr>
+            <a:r>
+              <a:t>SYSTEM ARCHITECTURE</a:t>
             </a:r>
           </a:p>
         </p:txBody>
@@ -3427,8 +3583,8 @@
         </p:nvSpPr>
         <p:spPr>
           <a:xfrm>
-            <a:off x="731520" y="1645920"/>
-            <a:ext cx="10698480" cy="4572000"/>
+            <a:off x="731520" y="548640"/>
+            <a:ext cx="10698480" cy="731520"/>
           </a:xfrm>
           <a:prstGeom prst="rect">
             <a:avLst/>
@@ -3436,17 +3592,13 @@
           <a:noFill/>
         </p:spPr>
         <p:txBody>
-          <a:bodyPr wrap="square">
+          <a:bodyPr wrap="none">
             <a:spAutoFit/>
           </a:bodyPr>
           <a:lstStyle/>
-          <a:p/>
-          <a:p>
-            <a:pPr>
-              <a:spcAft>
-                <a:spcPts val="2000"/>
-              </a:spcAft>
-              <a:defRPr sz="1800" b="1">
+          <a:p>
+            <a:pPr>
+              <a:defRPr sz="3200" b="1">
                 <a:solidFill>
                   <a:srgbClr val="FFD54F"/>
                 </a:solidFill>
@@ -3454,91 +3606,761 @@
               </a:defRPr>
             </a:pPr>
             <a:r>
-              <a:t>• Multi-Format Tokenizer: </a:t>
-            </a:r>
-            <a:r>
-              <a:rPr sz="1600" b="0">
-                <a:solidFill>
-                  <a:srgbClr val="FFFFFF"/>
-                </a:solidFill>
-                <a:latin typeface="Calibri"/>
-              </a:rPr>
-              <a:t>Automatically splits user inputs by commas, spaces, or newlines, running regex checks to extract playlist IDs, single video IDs, shorts, or standard URLs in one batch.</a:t>
-            </a:r>
-          </a:p>
-          <a:p>
-            <a:pPr>
-              <a:spcAft>
-                <a:spcPts val="2000"/>
-              </a:spcAft>
-              <a:defRPr sz="1800" b="1">
-                <a:solidFill>
-                  <a:srgbClr val="FFD54F"/>
-                </a:solidFill>
-                <a:latin typeface="Calibri"/>
-              </a:defRPr>
-            </a:pPr>
-            <a:r>
-              <a:t>• Recursion &amp; Pagination: </a:t>
-            </a:r>
-            <a:r>
-              <a:rPr sz="1600" b="0">
-                <a:solidFill>
-                  <a:srgbClr val="FFFFFF"/>
-                </a:solidFill>
-                <a:latin typeface="Calibri"/>
-              </a:rPr>
-              <a:t>Queries YouTube's `playlistItems` API recursively using page tokens to ingest lists of any size, handling up to thousands of videos.</a:t>
-            </a:r>
-          </a:p>
-          <a:p>
-            <a:pPr>
-              <a:spcAft>
-                <a:spcPts val="2000"/>
-              </a:spcAft>
-              <a:defRPr sz="1800" b="1">
-                <a:solidFill>
-                  <a:srgbClr val="FFD54F"/>
-                </a:solidFill>
-                <a:latin typeface="Calibri"/>
-              </a:defRPr>
-            </a:pPr>
-            <a:r>
-              <a:t>• Batch Duration Loader: </a:t>
-            </a:r>
-            <a:r>
-              <a:rPr sz="1600" b="0">
-                <a:solidFill>
-                  <a:srgbClr val="FFFFFF"/>
-                </a:solidFill>
-                <a:latin typeface="Calibri"/>
-              </a:rPr>
-              <a:t>To avoid exceeding API limits, gathers all video IDs and queries the YouTube `/videos` API in chunks of 50 to resolve durations in a single roundtrip.</a:t>
-            </a:r>
-          </a:p>
-          <a:p>
-            <a:pPr>
-              <a:spcAft>
-                <a:spcPts val="2000"/>
-              </a:spcAft>
-              <a:defRPr sz="1800" b="1">
-                <a:solidFill>
-                  <a:srgbClr val="FFD54F"/>
-                </a:solidFill>
-                <a:latin typeface="Calibri"/>
-              </a:defRPr>
-            </a:pPr>
-            <a:r>
-              <a:t>• ISO-8601 Duration Parser: </a:t>
-            </a:r>
-            <a:r>
-              <a:rPr sz="1600" b="0">
-                <a:solidFill>
-                  <a:srgbClr val="FFFFFF"/>
-                </a:solidFill>
-                <a:latin typeface="Calibri"/>
-              </a:rPr>
-              <a:t>Parses formats like `PT1H23M45S` into total integers of seconds using specialized regex capture groups for clean calculations.</a:t>
+              <a:t>Core Database Relational Schema</a:t>
+            </a:r>
+          </a:p>
+        </p:txBody>
+      </p:sp>
+      <p:sp>
+        <p:nvSpPr>
+          <p:cNvPr id="4" name="Rounded Rectangle 3"/>
+          <p:cNvSpPr/>
+          <p:nvPr/>
+        </p:nvSpPr>
+        <p:spPr>
+          <a:xfrm>
+            <a:off x="731520" y="1645920"/>
+            <a:ext cx="2468880" cy="4389120"/>
+          </a:xfrm>
+          <a:prstGeom prst="roundRect">
+            <a:avLst/>
+          </a:prstGeom>
+          <a:solidFill>
+            <a:srgbClr val="2D2D2D"/>
+          </a:solidFill>
+          <a:ln w="19050">
+            <a:solidFill>
+              <a:srgbClr val="505050"/>
+            </a:solidFill>
+          </a:ln>
+        </p:spPr>
+        <p:style>
+          <a:lnRef idx="1">
+            <a:schemeClr val="accent1"/>
+          </a:lnRef>
+          <a:fillRef idx="3">
+            <a:schemeClr val="accent1"/>
+          </a:fillRef>
+          <a:effectRef idx="2">
+            <a:schemeClr val="accent1"/>
+          </a:effectRef>
+          <a:fontRef idx="minor">
+            <a:schemeClr val="lt1"/>
+          </a:fontRef>
+        </p:style>
+        <p:txBody>
+          <a:bodyPr rtlCol="0" anchor="ctr" wrap="square" lIns="137160" tIns="137160" rIns="137160" bIns="137160"/>
+          <a:lstStyle/>
+          <a:p>
+            <a:pPr algn="ctr">
+              <a:spcAft>
+                <a:spcPts val="800"/>
+              </a:spcAft>
+              <a:defRPr sz="1600" b="1">
+                <a:solidFill>
+                  <a:srgbClr val="81D4FA"/>
+                </a:solidFill>
+                <a:latin typeface="Calibri"/>
+              </a:defRPr>
+            </a:pPr>
+            <a:r>
+              <a:t>subjects</a:t>
+            </a:r>
+          </a:p>
+          <a:p>
+            <a:pPr>
+              <a:spcAft>
+                <a:spcPts val="400"/>
+              </a:spcAft>
+              <a:defRPr sz="1300">
+                <a:solidFill>
+                  <a:srgbClr val="FFFFFF"/>
+                </a:solidFill>
+                <a:latin typeface="Calibri"/>
+              </a:defRPr>
+            </a:pPr>
+            <a:r>
+              <a:t>id [INT PK]</a:t>
+            </a:r>
+          </a:p>
+          <a:p>
+            <a:pPr>
+              <a:spcAft>
+                <a:spcPts val="400"/>
+              </a:spcAft>
+              <a:defRPr sz="1300">
+                <a:solidFill>
+                  <a:srgbClr val="FFFFFF"/>
+                </a:solidFill>
+                <a:latin typeface="Calibri"/>
+              </a:defRPr>
+            </a:pPr>
+            <a:r>
+              <a:t>user_id [INT FK]</a:t>
+            </a:r>
+          </a:p>
+          <a:p>
+            <a:pPr>
+              <a:spcAft>
+                <a:spcPts val="400"/>
+              </a:spcAft>
+              <a:defRPr sz="1300">
+                <a:solidFill>
+                  <a:srgbClr val="FFFFFF"/>
+                </a:solidFill>
+                <a:latin typeface="Calibri"/>
+              </a:defRPr>
+            </a:pPr>
+            <a:r>
+              <a:t>name [VARCHAR]</a:t>
+            </a:r>
+          </a:p>
+          <a:p>
+            <a:pPr>
+              <a:spcAft>
+                <a:spcPts val="400"/>
+              </a:spcAft>
+              <a:defRPr sz="1300">
+                <a:solidFill>
+                  <a:srgbClr val="FFFFFF"/>
+                </a:solidFill>
+                <a:latin typeface="Calibri"/>
+              </a:defRPr>
+            </a:pPr>
+            <a:r>
+              <a:t>description [TEXT]</a:t>
+            </a:r>
+          </a:p>
+          <a:p>
+            <a:pPr>
+              <a:spcAft>
+                <a:spcPts val="400"/>
+              </a:spcAft>
+              <a:defRPr sz="1300">
+                <a:solidFill>
+                  <a:srgbClr val="FFFFFF"/>
+                </a:solidFill>
+                <a:latin typeface="Calibri"/>
+              </a:defRPr>
+            </a:pPr>
+            <a:r>
+              <a:t>is_paused [BOOLEAN]</a:t>
+            </a:r>
+          </a:p>
+          <a:p>
+            <a:pPr>
+              <a:spcAft>
+                <a:spcPts val="400"/>
+              </a:spcAft>
+              <a:defRPr sz="1300">
+                <a:solidFill>
+                  <a:srgbClr val="FFFFFF"/>
+                </a:solidFill>
+                <a:latin typeface="Calibri"/>
+              </a:defRPr>
+            </a:pPr>
+            <a:r>
+              <a:t>paused_at [DATETIME]</a:t>
+            </a:r>
+          </a:p>
+          <a:p>
+            <a:pPr>
+              <a:spcAft>
+                <a:spcPts val="400"/>
+              </a:spcAft>
+              <a:defRPr sz="1300">
+                <a:solidFill>
+                  <a:srgbClr val="FFFFFF"/>
+                </a:solidFill>
+                <a:latin typeface="Calibri"/>
+              </a:defRPr>
+            </a:pPr>
+            <a:r>
+              <a:t>created_at [DATETIME]</a:t>
+            </a:r>
+          </a:p>
+        </p:txBody>
+      </p:sp>
+      <p:sp>
+        <p:nvSpPr>
+          <p:cNvPr id="5" name="Rounded Rectangle 4"/>
+          <p:cNvSpPr/>
+          <p:nvPr/>
+        </p:nvSpPr>
+        <p:spPr>
+          <a:xfrm>
+            <a:off x="3474720" y="1645920"/>
+            <a:ext cx="2468880" cy="4389120"/>
+          </a:xfrm>
+          <a:prstGeom prst="roundRect">
+            <a:avLst/>
+          </a:prstGeom>
+          <a:solidFill>
+            <a:srgbClr val="2D2D2D"/>
+          </a:solidFill>
+          <a:ln w="19050">
+            <a:solidFill>
+              <a:srgbClr val="505050"/>
+            </a:solidFill>
+          </a:ln>
+        </p:spPr>
+        <p:style>
+          <a:lnRef idx="1">
+            <a:schemeClr val="accent1"/>
+          </a:lnRef>
+          <a:fillRef idx="3">
+            <a:schemeClr val="accent1"/>
+          </a:fillRef>
+          <a:effectRef idx="2">
+            <a:schemeClr val="accent1"/>
+          </a:effectRef>
+          <a:fontRef idx="minor">
+            <a:schemeClr val="lt1"/>
+          </a:fontRef>
+        </p:style>
+        <p:txBody>
+          <a:bodyPr rtlCol="0" anchor="ctr" wrap="square" lIns="137160" tIns="137160" rIns="137160" bIns="137160"/>
+          <a:lstStyle/>
+          <a:p>
+            <a:pPr algn="ctr">
+              <a:spcAft>
+                <a:spcPts val="800"/>
+              </a:spcAft>
+              <a:defRPr sz="1600" b="1">
+                <a:solidFill>
+                  <a:srgbClr val="81D4FA"/>
+                </a:solidFill>
+                <a:latin typeface="Calibri"/>
+              </a:defRPr>
+            </a:pPr>
+            <a:r>
+              <a:t>lectures</a:t>
+            </a:r>
+          </a:p>
+          <a:p>
+            <a:pPr>
+              <a:spcAft>
+                <a:spcPts val="400"/>
+              </a:spcAft>
+              <a:defRPr sz="1300">
+                <a:solidFill>
+                  <a:srgbClr val="FFFFFF"/>
+                </a:solidFill>
+                <a:latin typeface="Calibri"/>
+              </a:defRPr>
+            </a:pPr>
+            <a:r>
+              <a:t>id [INT PK]</a:t>
+            </a:r>
+          </a:p>
+          <a:p>
+            <a:pPr>
+              <a:spcAft>
+                <a:spcPts val="400"/>
+              </a:spcAft>
+              <a:defRPr sz="1300">
+                <a:solidFill>
+                  <a:srgbClr val="FFFFFF"/>
+                </a:solidFill>
+                <a:latin typeface="Calibri"/>
+              </a:defRPr>
+            </a:pPr>
+            <a:r>
+              <a:t>subject_id [INT FK]</a:t>
+            </a:r>
+          </a:p>
+          <a:p>
+            <a:pPr>
+              <a:spcAft>
+                <a:spcPts val="400"/>
+              </a:spcAft>
+              <a:defRPr sz="1300">
+                <a:solidFill>
+                  <a:srgbClr val="FFFFFF"/>
+                </a:solidFill>
+                <a:latin typeface="Calibri"/>
+              </a:defRPr>
+            </a:pPr>
+            <a:r>
+              <a:t>title [VARCHAR]</a:t>
+            </a:r>
+          </a:p>
+          <a:p>
+            <a:pPr>
+              <a:spcAft>
+                <a:spcPts val="400"/>
+              </a:spcAft>
+              <a:defRPr sz="1300">
+                <a:solidFill>
+                  <a:srgbClr val="FFFFFF"/>
+                </a:solidFill>
+                <a:latin typeface="Calibri"/>
+              </a:defRPr>
+            </a:pPr>
+            <a:r>
+              <a:t>video_id [VARCHAR]</a:t>
+            </a:r>
+          </a:p>
+          <a:p>
+            <a:pPr>
+              <a:spcAft>
+                <a:spcPts val="400"/>
+              </a:spcAft>
+              <a:defRPr sz="1300">
+                <a:solidFill>
+                  <a:srgbClr val="FFFFFF"/>
+                </a:solidFill>
+                <a:latin typeface="Calibri"/>
+              </a:defRPr>
+            </a:pPr>
+            <a:r>
+              <a:t>lecture_order [INT]</a:t>
+            </a:r>
+          </a:p>
+          <a:p>
+            <a:pPr>
+              <a:spcAft>
+                <a:spcPts val="400"/>
+              </a:spcAft>
+              <a:defRPr sz="1300">
+                <a:solidFill>
+                  <a:srgbClr val="FFFFFF"/>
+                </a:solidFill>
+                <a:latin typeface="Calibri"/>
+              </a:defRPr>
+            </a:pPr>
+            <a:r>
+              <a:t>duration [INT]</a:t>
+            </a:r>
+          </a:p>
+          <a:p>
+            <a:pPr>
+              <a:spcAft>
+                <a:spcPts val="400"/>
+              </a:spcAft>
+              <a:defRPr sz="1300">
+                <a:solidFill>
+                  <a:srgbClr val="FFFFFF"/>
+                </a:solidFill>
+                <a:latin typeface="Calibri"/>
+              </a:defRPr>
+            </a:pPr>
+            <a:r>
+              <a:t>completed [BOOLEAN]</a:t>
+            </a:r>
+          </a:p>
+          <a:p>
+            <a:pPr>
+              <a:spcAft>
+                <a:spcPts val="400"/>
+              </a:spcAft>
+              <a:defRPr sz="1300">
+                <a:solidFill>
+                  <a:srgbClr val="FFFFFF"/>
+                </a:solidFill>
+                <a:latin typeface="Calibri"/>
+              </a:defRPr>
+            </a:pPr>
+            <a:r>
+              <a:t>completed_at [DATETIME]</a:t>
+            </a:r>
+          </a:p>
+        </p:txBody>
+      </p:sp>
+      <p:sp>
+        <p:nvSpPr>
+          <p:cNvPr id="6" name="Rounded Rectangle 5"/>
+          <p:cNvSpPr/>
+          <p:nvPr/>
+        </p:nvSpPr>
+        <p:spPr>
+          <a:xfrm>
+            <a:off x="6217920" y="1645920"/>
+            <a:ext cx="2468880" cy="2103120"/>
+          </a:xfrm>
+          <a:prstGeom prst="roundRect">
+            <a:avLst/>
+          </a:prstGeom>
+          <a:solidFill>
+            <a:srgbClr val="2D2D2D"/>
+          </a:solidFill>
+          <a:ln w="19050">
+            <a:solidFill>
+              <a:srgbClr val="505050"/>
+            </a:solidFill>
+          </a:ln>
+        </p:spPr>
+        <p:style>
+          <a:lnRef idx="1">
+            <a:schemeClr val="accent1"/>
+          </a:lnRef>
+          <a:fillRef idx="3">
+            <a:schemeClr val="accent1"/>
+          </a:fillRef>
+          <a:effectRef idx="2">
+            <a:schemeClr val="accent1"/>
+          </a:effectRef>
+          <a:fontRef idx="minor">
+            <a:schemeClr val="lt1"/>
+          </a:fontRef>
+        </p:style>
+        <p:txBody>
+          <a:bodyPr rtlCol="0" anchor="ctr" wrap="square" lIns="137160" tIns="137160" rIns="137160" bIns="137160"/>
+          <a:lstStyle/>
+          <a:p>
+            <a:pPr algn="ctr">
+              <a:spcAft>
+                <a:spcPts val="800"/>
+              </a:spcAft>
+              <a:defRPr sz="1600" b="1">
+                <a:solidFill>
+                  <a:srgbClr val="81D4FA"/>
+                </a:solidFill>
+                <a:latin typeface="Calibri"/>
+              </a:defRPr>
+            </a:pPr>
+            <a:r>
+              <a:t>study_plans</a:t>
+            </a:r>
+          </a:p>
+          <a:p>
+            <a:pPr>
+              <a:spcAft>
+                <a:spcPts val="400"/>
+              </a:spcAft>
+              <a:defRPr sz="1300">
+                <a:solidFill>
+                  <a:srgbClr val="FFFFFF"/>
+                </a:solidFill>
+                <a:latin typeface="Calibri"/>
+              </a:defRPr>
+            </a:pPr>
+            <a:r>
+              <a:t>id [INT PK]</a:t>
+            </a:r>
+          </a:p>
+          <a:p>
+            <a:pPr>
+              <a:spcAft>
+                <a:spcPts val="400"/>
+              </a:spcAft>
+              <a:defRPr sz="1300">
+                <a:solidFill>
+                  <a:srgbClr val="FFFFFF"/>
+                </a:solidFill>
+                <a:latin typeface="Calibri"/>
+              </a:defRPr>
+            </a:pPr>
+            <a:r>
+              <a:t>subject_id [INT FK]</a:t>
+            </a:r>
+          </a:p>
+          <a:p>
+            <a:pPr>
+              <a:spcAft>
+                <a:spcPts val="400"/>
+              </a:spcAft>
+              <a:defRPr sz="1300">
+                <a:solidFill>
+                  <a:srgbClr val="FFFFFF"/>
+                </a:solidFill>
+                <a:latin typeface="Calibri"/>
+              </a:defRPr>
+            </a:pPr>
+            <a:r>
+              <a:t>hours_per_day [FLOAT]</a:t>
+            </a:r>
+          </a:p>
+          <a:p>
+            <a:pPr>
+              <a:spcAft>
+                <a:spcPts val="400"/>
+              </a:spcAft>
+              <a:defRPr sz="1300">
+                <a:solidFill>
+                  <a:srgbClr val="FFFFFF"/>
+                </a:solidFill>
+                <a:latin typeface="Calibri"/>
+              </a:defRPr>
+            </a:pPr>
+            <a:r>
+              <a:t>start_date [DATE]</a:t>
+            </a:r>
+          </a:p>
+        </p:txBody>
+      </p:sp>
+      <p:sp>
+        <p:nvSpPr>
+          <p:cNvPr id="7" name="Rounded Rectangle 6"/>
+          <p:cNvSpPr/>
+          <p:nvPr/>
+        </p:nvSpPr>
+        <p:spPr>
+          <a:xfrm>
+            <a:off x="6217920" y="3931920"/>
+            <a:ext cx="2468880" cy="2103120"/>
+          </a:xfrm>
+          <a:prstGeom prst="roundRect">
+            <a:avLst/>
+          </a:prstGeom>
+          <a:solidFill>
+            <a:srgbClr val="2D2D2D"/>
+          </a:solidFill>
+          <a:ln w="19050">
+            <a:solidFill>
+              <a:srgbClr val="505050"/>
+            </a:solidFill>
+          </a:ln>
+        </p:spPr>
+        <p:style>
+          <a:lnRef idx="1">
+            <a:schemeClr val="accent1"/>
+          </a:lnRef>
+          <a:fillRef idx="3">
+            <a:schemeClr val="accent1"/>
+          </a:fillRef>
+          <a:effectRef idx="2">
+            <a:schemeClr val="accent1"/>
+          </a:effectRef>
+          <a:fontRef idx="minor">
+            <a:schemeClr val="lt1"/>
+          </a:fontRef>
+        </p:style>
+        <p:txBody>
+          <a:bodyPr rtlCol="0" anchor="ctr" wrap="square" lIns="137160" tIns="137160" rIns="137160" bIns="137160"/>
+          <a:lstStyle/>
+          <a:p>
+            <a:pPr algn="ctr">
+              <a:spcAft>
+                <a:spcPts val="800"/>
+              </a:spcAft>
+              <a:defRPr sz="1600" b="1">
+                <a:solidFill>
+                  <a:srgbClr val="81D4FA"/>
+                </a:solidFill>
+                <a:latin typeface="Calibri"/>
+              </a:defRPr>
+            </a:pPr>
+            <a:r>
+              <a:t>study_plan_days</a:t>
+            </a:r>
+          </a:p>
+          <a:p>
+            <a:pPr>
+              <a:spcAft>
+                <a:spcPts val="400"/>
+              </a:spcAft>
+              <a:defRPr sz="1300">
+                <a:solidFill>
+                  <a:srgbClr val="FFFFFF"/>
+                </a:solidFill>
+                <a:latin typeface="Calibri"/>
+              </a:defRPr>
+            </a:pPr>
+            <a:r>
+              <a:t>id [INT PK]</a:t>
+            </a:r>
+          </a:p>
+          <a:p>
+            <a:pPr>
+              <a:spcAft>
+                <a:spcPts val="400"/>
+              </a:spcAft>
+              <a:defRPr sz="1300">
+                <a:solidFill>
+                  <a:srgbClr val="FFFFFF"/>
+                </a:solidFill>
+                <a:latin typeface="Calibri"/>
+              </a:defRPr>
+            </a:pPr>
+            <a:r>
+              <a:t>plan_id [INT FK]</a:t>
+            </a:r>
+          </a:p>
+          <a:p>
+            <a:pPr>
+              <a:spcAft>
+                <a:spcPts val="400"/>
+              </a:spcAft>
+              <a:defRPr sz="1300">
+                <a:solidFill>
+                  <a:srgbClr val="FFFFFF"/>
+                </a:solidFill>
+                <a:latin typeface="Calibri"/>
+              </a:defRPr>
+            </a:pPr>
+            <a:r>
+              <a:t>day_number [INT]</a:t>
+            </a:r>
+          </a:p>
+          <a:p>
+            <a:pPr>
+              <a:spcAft>
+                <a:spcPts val="400"/>
+              </a:spcAft>
+              <a:defRPr sz="1300">
+                <a:solidFill>
+                  <a:srgbClr val="FFFFFF"/>
+                </a:solidFill>
+                <a:latin typeface="Calibri"/>
+              </a:defRPr>
+            </a:pPr>
+            <a:r>
+              <a:t>lecture_ids [JSON]</a:t>
+            </a:r>
+          </a:p>
+          <a:p>
+            <a:pPr>
+              <a:spcAft>
+                <a:spcPts val="400"/>
+              </a:spcAft>
+              <a:defRPr sz="1300">
+                <a:solidFill>
+                  <a:srgbClr val="FFFFFF"/>
+                </a:solidFill>
+                <a:latin typeface="Calibri"/>
+              </a:defRPr>
+            </a:pPr>
+            <a:r>
+              <a:t>total_duration [INT]</a:t>
+            </a:r>
+          </a:p>
+        </p:txBody>
+      </p:sp>
+      <p:sp>
+        <p:nvSpPr>
+          <p:cNvPr id="8" name="Rounded Rectangle 7"/>
+          <p:cNvSpPr/>
+          <p:nvPr/>
+        </p:nvSpPr>
+        <p:spPr>
+          <a:xfrm>
+            <a:off x="8961120" y="1645920"/>
+            <a:ext cx="2468880" cy="4389120"/>
+          </a:xfrm>
+          <a:prstGeom prst="roundRect">
+            <a:avLst/>
+          </a:prstGeom>
+          <a:solidFill>
+            <a:srgbClr val="2D2D2D"/>
+          </a:solidFill>
+          <a:ln w="19050">
+            <a:solidFill>
+              <a:srgbClr val="505050"/>
+            </a:solidFill>
+          </a:ln>
+        </p:spPr>
+        <p:style>
+          <a:lnRef idx="1">
+            <a:schemeClr val="accent1"/>
+          </a:lnRef>
+          <a:fillRef idx="3">
+            <a:schemeClr val="accent1"/>
+          </a:fillRef>
+          <a:effectRef idx="2">
+            <a:schemeClr val="accent1"/>
+          </a:effectRef>
+          <a:fontRef idx="minor">
+            <a:schemeClr val="lt1"/>
+          </a:fontRef>
+        </p:style>
+        <p:txBody>
+          <a:bodyPr rtlCol="0" anchor="ctr" wrap="square" lIns="137160" tIns="137160" rIns="137160" bIns="137160"/>
+          <a:lstStyle/>
+          <a:p>
+            <a:pPr algn="ctr">
+              <a:spcAft>
+                <a:spcPts val="800"/>
+              </a:spcAft>
+              <a:defRPr sz="1600" b="1">
+                <a:solidFill>
+                  <a:srgbClr val="81D4FA"/>
+                </a:solidFill>
+                <a:latin typeface="Calibri"/>
+              </a:defRPr>
+            </a:pPr>
+            <a:r>
+              <a:t>lecture_bookmarks</a:t>
+            </a:r>
+          </a:p>
+          <a:p>
+            <a:pPr>
+              <a:spcAft>
+                <a:spcPts val="400"/>
+              </a:spcAft>
+              <a:defRPr sz="1300">
+                <a:solidFill>
+                  <a:srgbClr val="FFFFFF"/>
+                </a:solidFill>
+                <a:latin typeface="Calibri"/>
+              </a:defRPr>
+            </a:pPr>
+            <a:r>
+              <a:t>id [INT PK]</a:t>
+            </a:r>
+          </a:p>
+          <a:p>
+            <a:pPr>
+              <a:spcAft>
+                <a:spcPts val="400"/>
+              </a:spcAft>
+              <a:defRPr sz="1300">
+                <a:solidFill>
+                  <a:srgbClr val="FFFFFF"/>
+                </a:solidFill>
+                <a:latin typeface="Calibri"/>
+              </a:defRPr>
+            </a:pPr>
+            <a:r>
+              <a:t>lecture_id [INT FK]</a:t>
+            </a:r>
+          </a:p>
+          <a:p>
+            <a:pPr>
+              <a:spcAft>
+                <a:spcPts val="400"/>
+              </a:spcAft>
+              <a:defRPr sz="1300">
+                <a:solidFill>
+                  <a:srgbClr val="FFFFFF"/>
+                </a:solidFill>
+                <a:latin typeface="Calibri"/>
+              </a:defRPr>
+            </a:pPr>
+            <a:r>
+              <a:t>timestamp [INT]</a:t>
+            </a:r>
+          </a:p>
+          <a:p>
+            <a:pPr>
+              <a:spcAft>
+                <a:spcPts val="400"/>
+              </a:spcAft>
+              <a:defRPr sz="1300">
+                <a:solidFill>
+                  <a:srgbClr val="FFFFFF"/>
+                </a:solidFill>
+                <a:latin typeface="Calibri"/>
+              </a:defRPr>
+            </a:pPr>
+            <a:r>
+              <a:t>note [VARCHAR(500)]</a:t>
+            </a:r>
+          </a:p>
+          <a:p>
+            <a:pPr>
+              <a:spcAft>
+                <a:spcPts val="400"/>
+              </a:spcAft>
+              <a:defRPr sz="1300">
+                <a:solidFill>
+                  <a:srgbClr val="FFFFFF"/>
+                </a:solidFill>
+                <a:latin typeface="Calibri"/>
+              </a:defRPr>
+            </a:pPr>
+            <a:r>
+              <a:t>created_at [DATETIME]</a:t>
             </a:r>
           </a:p>
         </p:txBody>
@@ -3557,7 +4379,7 @@
     <p:bg>
       <p:bgPr>
         <a:solidFill>
-          <a:srgbClr val="212121"/>
+          <a:srgbClr val="1E1E1E"/>
         </a:solidFill>
         <a:effectLst/>
       </p:bgPr>
@@ -3577,8 +4399,8 @@
         </p:nvSpPr>
         <p:spPr>
           <a:xfrm>
-            <a:off x="731520" y="548640"/>
-            <a:ext cx="10698480" cy="914400"/>
+            <a:off x="731520" y="365760"/>
+            <a:ext cx="10698480" cy="365760"/>
           </a:xfrm>
           <a:prstGeom prst="rect">
             <a:avLst/>
@@ -3586,21 +4408,21 @@
           <a:noFill/>
         </p:spPr>
         <p:txBody>
-          <a:bodyPr wrap="square">
+          <a:bodyPr wrap="none">
             <a:spAutoFit/>
           </a:bodyPr>
           <a:lstStyle/>
           <a:p>
             <a:pPr>
-              <a:defRPr sz="3600" b="1">
-                <a:solidFill>
-                  <a:srgbClr val="FFD54F"/>
-                </a:solidFill>
-                <a:latin typeface="Calibri"/>
-              </a:defRPr>
-            </a:pPr>
-            <a:r>
-              <a:t>3. Day Partitioning &amp; Load Balancing Algorithms</a:t>
+              <a:defRPr sz="1100" b="1">
+                <a:solidFill>
+                  <a:srgbClr val="F48FB1"/>
+                </a:solidFill>
+                <a:latin typeface="Calibri"/>
+              </a:defRPr>
+            </a:pPr>
+            <a:r>
+              <a:t>SYSTEM LOGIC</a:t>
             </a:r>
           </a:p>
         </p:txBody>
@@ -3613,8 +4435,8 @@
         </p:nvSpPr>
         <p:spPr>
           <a:xfrm>
-            <a:off x="731520" y="1645920"/>
-            <a:ext cx="10698480" cy="4572000"/>
+            <a:off x="731520" y="548640"/>
+            <a:ext cx="10698480" cy="731520"/>
           </a:xfrm>
           <a:prstGeom prst="rect">
             <a:avLst/>
@@ -3622,84 +4444,329 @@
           <a:noFill/>
         </p:spPr>
         <p:txBody>
-          <a:bodyPr wrap="square">
+          <a:bodyPr wrap="none">
             <a:spAutoFit/>
           </a:bodyPr>
           <a:lstStyle/>
-          <a:p/>
-          <a:p>
-            <a:pPr>
-              <a:spcAft>
-                <a:spcPts val="2000"/>
-              </a:spcAft>
-              <a:defRPr sz="1800" b="1">
-                <a:solidFill>
-                  <a:srgbClr val="F06292"/>
-                </a:solidFill>
-                <a:latin typeface="Calibri"/>
-              </a:defRPr>
-            </a:pPr>
-            <a:r>
-              <a:t>• Greedy Packing (Hours/Day Constraint): </a:t>
-            </a:r>
-            <a:r>
-              <a:rPr sz="1600" b="0">
-                <a:solidFill>
-                  <a:srgbClr val="FFFFFF"/>
-                </a:solidFill>
-                <a:latin typeface="Calibri"/>
-              </a:rPr>
-              <a:t>Sequentially packs lecture durations into Day 1. If adding the next lecture exceeds the target daily limit, the day is sealed and a new day is initialized.</a:t>
-            </a:r>
-          </a:p>
-          <a:p>
-            <a:pPr>
-              <a:spcAft>
-                <a:spcPts val="2000"/>
-              </a:spcAft>
-              <a:defRPr sz="1800" b="1">
-                <a:solidFill>
-                  <a:srgbClr val="F06292"/>
-                </a:solidFill>
-                <a:latin typeface="Calibri"/>
-              </a:defRPr>
-            </a:pPr>
-            <a:r>
-              <a:t>• Balanced Load Partitioning (Days Count Constraint): </a:t>
-            </a:r>
-            <a:r>
-              <a:rPr sz="1600" b="0">
-                <a:solidFill>
-                  <a:srgbClr val="FFFFFF"/>
-                </a:solidFill>
-                <a:latin typeface="Calibri"/>
-              </a:rPr>
-              <a:t>Distributes all lectures over a target number of days ($D$) to minimize daily workload imbalances. It calculates the cumulative durations sum, divides it by $D$, and finds the closest partition lines mathematically.</a:t>
-            </a:r>
-          </a:p>
-          <a:p>
-            <a:pPr>
-              <a:spcAft>
-                <a:spcPts val="2000"/>
-              </a:spcAft>
-              <a:defRPr sz="1800" b="1">
-                <a:solidFill>
-                  <a:srgbClr val="F06292"/>
-                </a:solidFill>
-                <a:latin typeface="Calibri"/>
-              </a:defRPr>
-            </a:pPr>
-            <a:r>
-              <a:t>• Real-time Plan Regeneration: </a:t>
-            </a:r>
-            <a:r>
-              <a:rPr sz="1600" b="0">
-                <a:solidFill>
-                  <a:srgbClr val="FFFFFF"/>
-                </a:solidFill>
-                <a:latin typeface="Calibri"/>
-              </a:rPr>
-              <a:t>Regenerates all database day allocations instantly when target parameters or available hours are changed, updating the calendar grid.</a:t>
+          <a:p>
+            <a:pPr>
+              <a:defRPr sz="3200" b="1">
+                <a:solidFill>
+                  <a:srgbClr val="FFD54F"/>
+                </a:solidFill>
+                <a:latin typeface="Calibri"/>
+              </a:defRPr>
+            </a:pPr>
+            <a:r>
+              <a:t>Data Flow Diagram (DFD) &amp; Core Use Cases</a:t>
+            </a:r>
+          </a:p>
+        </p:txBody>
+      </p:sp>
+      <p:sp>
+        <p:nvSpPr>
+          <p:cNvPr id="4" name="Rounded Rectangle 3"/>
+          <p:cNvSpPr/>
+          <p:nvPr/>
+        </p:nvSpPr>
+        <p:spPr>
+          <a:xfrm>
+            <a:off x="731520" y="1645920"/>
+            <a:ext cx="5120640" cy="4389120"/>
+          </a:xfrm>
+          <a:prstGeom prst="roundRect">
+            <a:avLst/>
+          </a:prstGeom>
+          <a:solidFill>
+            <a:srgbClr val="2D2D2D"/>
+          </a:solidFill>
+          <a:ln w="19050">
+            <a:solidFill>
+              <a:srgbClr val="505050"/>
+            </a:solidFill>
+          </a:ln>
+        </p:spPr>
+        <p:style>
+          <a:lnRef idx="1">
+            <a:schemeClr val="accent1"/>
+          </a:lnRef>
+          <a:fillRef idx="3">
+            <a:schemeClr val="accent1"/>
+          </a:fillRef>
+          <a:effectRef idx="2">
+            <a:schemeClr val="accent1"/>
+          </a:effectRef>
+          <a:fontRef idx="minor">
+            <a:schemeClr val="lt1"/>
+          </a:fontRef>
+        </p:style>
+        <p:txBody>
+          <a:bodyPr rtlCol="0" anchor="ctr" wrap="square" lIns="137160" tIns="137160" rIns="137160" bIns="137160"/>
+          <a:lstStyle/>
+          <a:p>
+            <a:pPr algn="ctr">
+              <a:spcAft>
+                <a:spcPts val="800"/>
+              </a:spcAft>
+              <a:defRPr sz="1600" b="1">
+                <a:solidFill>
+                  <a:srgbClr val="FFD54F"/>
+                </a:solidFill>
+                <a:latin typeface="Calibri"/>
+              </a:defRPr>
+            </a:pPr>
+            <a:r>
+              <a:t>👥 Core Student Use Cases</a:t>
+            </a:r>
+          </a:p>
+          <a:p>
+            <a:pPr>
+              <a:spcAft>
+                <a:spcPts val="400"/>
+              </a:spcAft>
+              <a:defRPr sz="1300">
+                <a:solidFill>
+                  <a:srgbClr val="FFFFFF"/>
+                </a:solidFill>
+                <a:latin typeface="Calibri"/>
+              </a:defRPr>
+            </a:pPr>
+            <a:r>
+              <a:t>1. Subject Setup &amp; Video Import:</a:t>
+            </a:r>
+          </a:p>
+          <a:p>
+            <a:pPr>
+              <a:spcAft>
+                <a:spcPts val="400"/>
+              </a:spcAft>
+              <a:defRPr sz="1300">
+                <a:solidFill>
+                  <a:srgbClr val="FFFFFF"/>
+                </a:solidFill>
+                <a:latin typeface="Calibri"/>
+              </a:defRPr>
+            </a:pPr>
+            <a:r>
+              <a:t>   - Student pastes playlist or single video links.</a:t>
+            </a:r>
+          </a:p>
+          <a:p>
+            <a:pPr>
+              <a:spcAft>
+                <a:spcPts val="400"/>
+              </a:spcAft>
+              <a:defRPr sz="1300">
+                <a:solidFill>
+                  <a:srgbClr val="FFFFFF"/>
+                </a:solidFill>
+                <a:latin typeface="Calibri"/>
+              </a:defRPr>
+            </a:pPr>
+            <a:r>
+              <a:t>2. Study Plan Generation:</a:t>
+            </a:r>
+          </a:p>
+          <a:p>
+            <a:pPr>
+              <a:spcAft>
+                <a:spcPts val="400"/>
+              </a:spcAft>
+              <a:defRPr sz="1300">
+                <a:solidFill>
+                  <a:srgbClr val="FFFFFF"/>
+                </a:solidFill>
+                <a:latin typeface="Calibri"/>
+              </a:defRPr>
+            </a:pPr>
+            <a:r>
+              <a:t>   - Student sets daily target study hours or target days.</a:t>
+            </a:r>
+          </a:p>
+          <a:p>
+            <a:pPr>
+              <a:spcAft>
+                <a:spcPts val="400"/>
+              </a:spcAft>
+              <a:defRPr sz="1300">
+                <a:solidFill>
+                  <a:srgbClr val="FFFFFF"/>
+                </a:solidFill>
+                <a:latin typeface="Calibri"/>
+              </a:defRPr>
+            </a:pPr>
+            <a:r>
+              <a:t>3. Progress Logging:</a:t>
+            </a:r>
+          </a:p>
+          <a:p>
+            <a:pPr>
+              <a:spcAft>
+                <a:spcPts val="400"/>
+              </a:spcAft>
+              <a:defRPr sz="1300">
+                <a:solidFill>
+                  <a:srgbClr val="FFFFFF"/>
+                </a:solidFill>
+                <a:latin typeface="Calibri"/>
+              </a:defRPr>
+            </a:pPr>
+            <a:r>
+              <a:t>   - Student checks off completed lectures and views charts.</a:t>
+            </a:r>
+          </a:p>
+          <a:p>
+            <a:pPr>
+              <a:spcAft>
+                <a:spcPts val="400"/>
+              </a:spcAft>
+              <a:defRPr sz="1300">
+                <a:solidFill>
+                  <a:srgbClr val="FFFFFF"/>
+                </a:solidFill>
+                <a:latin typeface="Calibri"/>
+              </a:defRPr>
+            </a:pPr>
+            <a:r>
+              <a:t>4. Dynamic Calibration:</a:t>
+            </a:r>
+          </a:p>
+          <a:p>
+            <a:pPr>
+              <a:spcAft>
+                <a:spcPts val="400"/>
+              </a:spcAft>
+              <a:defRPr sz="1300">
+                <a:solidFill>
+                  <a:srgbClr val="FFFFFF"/>
+                </a:solidFill>
+                <a:latin typeface="Calibri"/>
+              </a:defRPr>
+            </a:pPr>
+            <a:r>
+              <a:t>   - Student pauses subject, resumes, or adjusts plan when behind.</a:t>
+            </a:r>
+          </a:p>
+        </p:txBody>
+      </p:sp>
+      <p:sp>
+        <p:nvSpPr>
+          <p:cNvPr id="5" name="Rounded Rectangle 4"/>
+          <p:cNvSpPr/>
+          <p:nvPr/>
+        </p:nvSpPr>
+        <p:spPr>
+          <a:xfrm>
+            <a:off x="6217920" y="1645920"/>
+            <a:ext cx="5120640" cy="4389120"/>
+          </a:xfrm>
+          <a:prstGeom prst="roundRect">
+            <a:avLst/>
+          </a:prstGeom>
+          <a:solidFill>
+            <a:srgbClr val="2D2D2D"/>
+          </a:solidFill>
+          <a:ln w="19050">
+            <a:solidFill>
+              <a:srgbClr val="505050"/>
+            </a:solidFill>
+          </a:ln>
+        </p:spPr>
+        <p:style>
+          <a:lnRef idx="1">
+            <a:schemeClr val="accent1"/>
+          </a:lnRef>
+          <a:fillRef idx="3">
+            <a:schemeClr val="accent1"/>
+          </a:fillRef>
+          <a:effectRef idx="2">
+            <a:schemeClr val="accent1"/>
+          </a:effectRef>
+          <a:fontRef idx="minor">
+            <a:schemeClr val="lt1"/>
+          </a:fontRef>
+        </p:style>
+        <p:txBody>
+          <a:bodyPr rtlCol="0" anchor="ctr" wrap="square" lIns="137160" tIns="137160" rIns="137160" bIns="137160"/>
+          <a:lstStyle/>
+          <a:p>
+            <a:pPr algn="ctr">
+              <a:spcAft>
+                <a:spcPts val="800"/>
+              </a:spcAft>
+              <a:defRPr sz="1600" b="1">
+                <a:solidFill>
+                  <a:srgbClr val="81D4FA"/>
+                </a:solidFill>
+                <a:latin typeface="Calibri"/>
+              </a:defRPr>
+            </a:pPr>
+            <a:r>
+              <a:t>🔄 Data Flow Mechanics</a:t>
+            </a:r>
+          </a:p>
+          <a:p>
+            <a:pPr>
+              <a:spcAft>
+                <a:spcPts val="400"/>
+              </a:spcAft>
+              <a:defRPr sz="1300">
+                <a:solidFill>
+                  <a:srgbClr val="FFFFFF"/>
+                </a:solidFill>
+                <a:latin typeface="Calibri"/>
+              </a:defRPr>
+            </a:pPr>
+            <a:r>
+              <a:t>• Input Stage: Paste URL strings -&gt; Backend Tokenizer parses items.</a:t>
+            </a:r>
+          </a:p>
+          <a:p>
+            <a:pPr>
+              <a:spcAft>
+                <a:spcPts val="400"/>
+              </a:spcAft>
+              <a:defRPr sz="1300">
+                <a:solidFill>
+                  <a:srgbClr val="FFFFFF"/>
+                </a:solidFill>
+                <a:latin typeface="Calibri"/>
+              </a:defRPr>
+            </a:pPr>
+            <a:r>
+              <a:t>• Ingest Stage: Backend queries YouTube API for metadata (durations, titles) -&gt; Writes to LECTURES table.</a:t>
+            </a:r>
+          </a:p>
+          <a:p>
+            <a:pPr>
+              <a:spcAft>
+                <a:spcPts val="400"/>
+              </a:spcAft>
+              <a:defRPr sz="1300">
+                <a:solidFill>
+                  <a:srgbClr val="FFFFFF"/>
+                </a:solidFill>
+                <a:latin typeface="Calibri"/>
+              </a:defRPr>
+            </a:pPr>
+            <a:r>
+              <a:t>• Partition Stage: Greedy or DP Load Balancing -&gt; populates STUDY_PLAN_DAYS table.</a:t>
+            </a:r>
+          </a:p>
+          <a:p>
+            <a:pPr>
+              <a:spcAft>
+                <a:spcPts val="400"/>
+              </a:spcAft>
+              <a:defRPr sz="1300">
+                <a:solidFill>
+                  <a:srgbClr val="FFFFFF"/>
+                </a:solidFill>
+                <a:latin typeface="Calibri"/>
+              </a:defRPr>
+            </a:pPr>
+            <a:r>
+              <a:t>• Interactive Cycle: Checkbox toggled -&gt; updates LECTURES table -&gt; triggers database triggers to write PROGRESS_SNAPSHOTS -&gt; refreshes Recharts UI.</a:t>
             </a:r>
           </a:p>
         </p:txBody>
@@ -3718,7 +4785,7 @@
     <p:bg>
       <p:bgPr>
         <a:solidFill>
-          <a:srgbClr val="212121"/>
+          <a:srgbClr val="1E1E1E"/>
         </a:solidFill>
         <a:effectLst/>
       </p:bgPr>
@@ -3738,8 +4805,8 @@
         </p:nvSpPr>
         <p:spPr>
           <a:xfrm>
-            <a:off x="731520" y="548640"/>
-            <a:ext cx="10698480" cy="914400"/>
+            <a:off x="731520" y="365760"/>
+            <a:ext cx="10698480" cy="365760"/>
           </a:xfrm>
           <a:prstGeom prst="rect">
             <a:avLst/>
@@ -3747,21 +4814,21 @@
           <a:noFill/>
         </p:spPr>
         <p:txBody>
-          <a:bodyPr wrap="square">
+          <a:bodyPr wrap="none">
             <a:spAutoFit/>
           </a:bodyPr>
           <a:lstStyle/>
           <a:p>
             <a:pPr>
-              <a:defRPr sz="3600" b="1">
-                <a:solidFill>
-                  <a:srgbClr val="FFD54F"/>
-                </a:solidFill>
-                <a:latin typeface="Calibri"/>
-              </a:defRPr>
-            </a:pPr>
-            <a:r>
-              <a:t>4. Chronological Alignment &amp; Adaptive Scheduling</a:t>
+              <a:defRPr sz="1100" b="1">
+                <a:solidFill>
+                  <a:srgbClr val="F48FB1"/>
+                </a:solidFill>
+                <a:latin typeface="Calibri"/>
+              </a:defRPr>
+            </a:pPr>
+            <a:r>
+              <a:t>USER EXPERIENCE</a:t>
             </a:r>
           </a:p>
         </p:txBody>
@@ -3774,8 +4841,8 @@
         </p:nvSpPr>
         <p:spPr>
           <a:xfrm>
-            <a:off x="731520" y="1645920"/>
-            <a:ext cx="10698480" cy="4572000"/>
+            <a:off x="731520" y="548640"/>
+            <a:ext cx="10698480" cy="731520"/>
           </a:xfrm>
           <a:prstGeom prst="rect">
             <a:avLst/>
@@ -3783,109 +4850,329 @@
           <a:noFill/>
         </p:spPr>
         <p:txBody>
-          <a:bodyPr wrap="square">
+          <a:bodyPr wrap="none">
             <a:spAutoFit/>
           </a:bodyPr>
           <a:lstStyle/>
-          <a:p/>
-          <a:p>
-            <a:pPr>
-              <a:spcAft>
-                <a:spcPts val="1600"/>
-              </a:spcAft>
-              <a:defRPr sz="1800" b="1">
-                <a:solidFill>
-                  <a:srgbClr val="4FC3F7"/>
-                </a:solidFill>
-                <a:latin typeface="Calibri"/>
-              </a:defRPr>
-            </a:pPr>
-            <a:r>
-              <a:t>• Alignment with Subject Creation: </a:t>
-            </a:r>
-            <a:r>
-              <a:rPr sz="1600" b="0">
-                <a:solidFill>
-                  <a:srgbClr val="FFFFFF"/>
-                </a:solidFill>
-                <a:latin typeface="Calibri"/>
-              </a:rPr>
-              <a:t>Instead of starting fresh on Day 1 today, the plan start date is locked to the Subject Creation Date (e.g. July 11th). This maps past days naturally.</a:t>
-            </a:r>
-          </a:p>
-          <a:p>
-            <a:pPr>
-              <a:spcAft>
-                <a:spcPts val="1600"/>
-              </a:spcAft>
-              <a:defRPr sz="1800" b="1">
-                <a:solidFill>
-                  <a:srgbClr val="4FC3F7"/>
-                </a:solidFill>
-                <a:latin typeface="Calibri"/>
-              </a:defRPr>
-            </a:pPr>
-            <a:r>
-              <a:t>• Chrono-Sorting Completed vs Uncompleted: </a:t>
-            </a:r>
-            <a:r>
-              <a:rPr sz="1600" b="0">
-                <a:solidFill>
-                  <a:srgbClr val="FFFFFF"/>
-                </a:solidFill>
-                <a:latin typeface="Calibri"/>
-              </a:rPr>
-              <a:t>When partitioning, already-completed lectures are automatically grouped and distributed in the past days (Day 1 to Yesterday).</a:t>
-            </a:r>
-          </a:p>
-          <a:p>
-            <a:pPr>
-              <a:spcAft>
-                <a:spcPts val="1600"/>
-              </a:spcAft>
-              <a:defRPr sz="1800" b="1">
-                <a:solidFill>
-                  <a:srgbClr val="4FC3F7"/>
-                </a:solidFill>
-                <a:latin typeface="Calibri"/>
-              </a:defRPr>
-            </a:pPr>
-            <a:r>
-              <a:t>• Today's Study Assignment: </a:t>
-            </a:r>
-            <a:r>
-              <a:rPr sz="1600" b="0">
-                <a:solidFill>
-                  <a:srgbClr val="FFFFFF"/>
-                </a:solidFill>
-                <a:latin typeface="Calibri"/>
-              </a:rPr>
-              <a:t>Uncompleted lectures are partitioned starting from Today's calendar day onwards, ensuring the user immediately sees the correct next task.</a:t>
-            </a:r>
-          </a:p>
-          <a:p>
-            <a:pPr>
-              <a:spcAft>
-                <a:spcPts val="1600"/>
-              </a:spcAft>
-              <a:defRPr sz="1800" b="1">
-                <a:solidFill>
-                  <a:srgbClr val="4FC3F7"/>
-                </a:solidFill>
-                <a:latin typeface="Calibri"/>
-              </a:defRPr>
-            </a:pPr>
-            <a:r>
-              <a:t>• Dynamic 'Adjust Schedule' Action: </a:t>
-            </a:r>
-            <a:r>
-              <a:rPr sz="1600" b="0">
-                <a:solidFill>
-                  <a:srgbClr val="FFFFFF"/>
-                </a:solidFill>
-                <a:latin typeface="Calibri"/>
-              </a:rPr>
-              <a:t>Recalculates the remaining days of the study plan, keeping completed tasks in the past and distributing only the remaining uncompleted load over future days.</a:t>
+          <a:p>
+            <a:pPr>
+              <a:defRPr sz="3200" b="1">
+                <a:solidFill>
+                  <a:srgbClr val="FFD54F"/>
+                </a:solidFill>
+                <a:latin typeface="Calibri"/>
+              </a:defRPr>
+            </a:pPr>
+            <a:r>
+              <a:t>Output Screens &amp; Interface Layouts</a:t>
+            </a:r>
+          </a:p>
+        </p:txBody>
+      </p:sp>
+      <p:sp>
+        <p:nvSpPr>
+          <p:cNvPr id="4" name="Rounded Rectangle 3"/>
+          <p:cNvSpPr/>
+          <p:nvPr/>
+        </p:nvSpPr>
+        <p:spPr>
+          <a:xfrm>
+            <a:off x="731520" y="1645920"/>
+            <a:ext cx="5120640" cy="4389120"/>
+          </a:xfrm>
+          <a:prstGeom prst="roundRect">
+            <a:avLst/>
+          </a:prstGeom>
+          <a:solidFill>
+            <a:srgbClr val="2D2D2D"/>
+          </a:solidFill>
+          <a:ln w="19050">
+            <a:solidFill>
+              <a:srgbClr val="505050"/>
+            </a:solidFill>
+          </a:ln>
+        </p:spPr>
+        <p:style>
+          <a:lnRef idx="1">
+            <a:schemeClr val="accent1"/>
+          </a:lnRef>
+          <a:fillRef idx="3">
+            <a:schemeClr val="accent1"/>
+          </a:fillRef>
+          <a:effectRef idx="2">
+            <a:schemeClr val="accent1"/>
+          </a:effectRef>
+          <a:fontRef idx="minor">
+            <a:schemeClr val="lt1"/>
+          </a:fontRef>
+        </p:style>
+        <p:txBody>
+          <a:bodyPr rtlCol="0" anchor="ctr" wrap="square" lIns="137160" tIns="137160" rIns="137160" bIns="137160"/>
+          <a:lstStyle/>
+          <a:p>
+            <a:pPr algn="ctr">
+              <a:spcAft>
+                <a:spcPts val="800"/>
+              </a:spcAft>
+              <a:defRPr sz="1600" b="1">
+                <a:solidFill>
+                  <a:srgbClr val="A5D6A7"/>
+                </a:solidFill>
+                <a:latin typeface="Calibri"/>
+              </a:defRPr>
+            </a:pPr>
+            <a:r>
+              <a:t>🖥️ Course Dashboard &amp; Study Planner</a:t>
+            </a:r>
+          </a:p>
+          <a:p>
+            <a:pPr>
+              <a:spcAft>
+                <a:spcPts val="400"/>
+              </a:spcAft>
+              <a:defRPr sz="1300">
+                <a:solidFill>
+                  <a:srgbClr val="FFFFFF"/>
+                </a:solidFill>
+                <a:latin typeface="Calibri"/>
+              </a:defRPr>
+            </a:pPr>
+            <a:r>
+              <a:t>• Dashboard Page:</a:t>
+            </a:r>
+          </a:p>
+          <a:p>
+            <a:pPr>
+              <a:spcAft>
+                <a:spcPts val="400"/>
+              </a:spcAft>
+              <a:defRPr sz="1300">
+                <a:solidFill>
+                  <a:srgbClr val="FFFFFF"/>
+                </a:solidFill>
+                <a:latin typeface="Calibri"/>
+              </a:defRPr>
+            </a:pPr>
+            <a:r>
+              <a:t>  - Grid cards for each subject displaying name, description, paused badge, and progress completion percentages.</a:t>
+            </a:r>
+          </a:p>
+          <a:p>
+            <a:pPr>
+              <a:spcAft>
+                <a:spcPts val="400"/>
+              </a:spcAft>
+              <a:defRPr sz="1300">
+                <a:solidFill>
+                  <a:srgbClr val="FFFFFF"/>
+                </a:solidFill>
+                <a:latin typeface="Calibri"/>
+              </a:defRPr>
+            </a:pPr>
+            <a:r>
+              <a:t>• Study Planner Tab:</a:t>
+            </a:r>
+          </a:p>
+          <a:p>
+            <a:pPr>
+              <a:spcAft>
+                <a:spcPts val="400"/>
+              </a:spcAft>
+              <a:defRPr sz="1300">
+                <a:solidFill>
+                  <a:srgbClr val="FFFFFF"/>
+                </a:solidFill>
+                <a:latin typeface="Calibri"/>
+              </a:defRPr>
+            </a:pPr>
+            <a:r>
+              <a:t>  - TODAY'S STUDY ASSIGNMENT: Card showing list of uncompleted lectures planned for the current day.</a:t>
+            </a:r>
+          </a:p>
+          <a:p>
+            <a:pPr>
+              <a:spcAft>
+                <a:spcPts val="400"/>
+              </a:spcAft>
+              <a:defRPr sz="1300">
+                <a:solidFill>
+                  <a:srgbClr val="FFFFFF"/>
+                </a:solidFill>
+                <a:latin typeface="Calibri"/>
+              </a:defRPr>
+            </a:pPr>
+            <a:r>
+              <a:t>  - Full Workbook Timeline: Sequential accordion showing what lectures are scheduled for Day 1, Day 2, etc.</a:t>
+            </a:r>
+          </a:p>
+          <a:p>
+            <a:pPr>
+              <a:spcAft>
+                <a:spcPts val="400"/>
+              </a:spcAft>
+              <a:defRPr sz="1300">
+                <a:solidFill>
+                  <a:srgbClr val="FFFFFF"/>
+                </a:solidFill>
+                <a:latin typeface="Calibri"/>
+              </a:defRPr>
+            </a:pPr>
+            <a:r>
+              <a:t>  - Plan deviation alert: Green (ahead), Orange (on track), or Pink (behind) banner with 'Adjust Schedule' button.</a:t>
+            </a:r>
+          </a:p>
+        </p:txBody>
+      </p:sp>
+      <p:sp>
+        <p:nvSpPr>
+          <p:cNvPr id="5" name="Rounded Rectangle 4"/>
+          <p:cNvSpPr/>
+          <p:nvPr/>
+        </p:nvSpPr>
+        <p:spPr>
+          <a:xfrm>
+            <a:off x="6217920" y="1645920"/>
+            <a:ext cx="5120640" cy="4389120"/>
+          </a:xfrm>
+          <a:prstGeom prst="roundRect">
+            <a:avLst/>
+          </a:prstGeom>
+          <a:solidFill>
+            <a:srgbClr val="2D2D2D"/>
+          </a:solidFill>
+          <a:ln w="19050">
+            <a:solidFill>
+              <a:srgbClr val="505050"/>
+            </a:solidFill>
+          </a:ln>
+        </p:spPr>
+        <p:style>
+          <a:lnRef idx="1">
+            <a:schemeClr val="accent1"/>
+          </a:lnRef>
+          <a:fillRef idx="3">
+            <a:schemeClr val="accent1"/>
+          </a:fillRef>
+          <a:effectRef idx="2">
+            <a:schemeClr val="accent1"/>
+          </a:effectRef>
+          <a:fontRef idx="minor">
+            <a:schemeClr val="lt1"/>
+          </a:fontRef>
+        </p:style>
+        <p:txBody>
+          <a:bodyPr rtlCol="0" anchor="ctr" wrap="square" lIns="137160" tIns="137160" rIns="137160" bIns="137160"/>
+          <a:lstStyle/>
+          <a:p>
+            <a:pPr algn="ctr">
+              <a:spcAft>
+                <a:spcPts val="800"/>
+              </a:spcAft>
+              <a:defRPr sz="1600" b="1">
+                <a:solidFill>
+                  <a:srgbClr val="81D4FA"/>
+                </a:solidFill>
+                <a:latin typeface="Calibri"/>
+              </a:defRPr>
+            </a:pPr>
+            <a:r>
+              <a:t>📺 Video Workspace &amp; Progress Chart</a:t>
+            </a:r>
+          </a:p>
+          <a:p>
+            <a:pPr>
+              <a:spcAft>
+                <a:spcPts val="400"/>
+              </a:spcAft>
+              <a:defRPr sz="1300">
+                <a:solidFill>
+                  <a:srgbClr val="FFFFFF"/>
+                </a:solidFill>
+                <a:latin typeface="Calibri"/>
+              </a:defRPr>
+            </a:pPr>
+            <a:r>
+              <a:t>• Split-Screen Player Workspace:</a:t>
+            </a:r>
+          </a:p>
+          <a:p>
+            <a:pPr>
+              <a:spcAft>
+                <a:spcPts val="400"/>
+              </a:spcAft>
+              <a:defRPr sz="1300">
+                <a:solidFill>
+                  <a:srgbClr val="FFFFFF"/>
+                </a:solidFill>
+                <a:latin typeface="Calibri"/>
+              </a:defRPr>
+            </a:pPr>
+            <a:r>
+              <a:t>  - Embedded YouTube Player iframe loading the selected video with playback hooks.</a:t>
+            </a:r>
+          </a:p>
+          <a:p>
+            <a:pPr>
+              <a:spcAft>
+                <a:spcPts val="400"/>
+              </a:spcAft>
+              <a:defRPr sz="1300">
+                <a:solidFill>
+                  <a:srgbClr val="FFFFFF"/>
+                </a:solidFill>
+                <a:latin typeface="Calibri"/>
+              </a:defRPr>
+            </a:pPr>
+            <a:r>
+              <a:t>  - Interactive Bookmark Panel: List of notes pinned to specific timestamps. Pin button captures current player seconds.</a:t>
+            </a:r>
+          </a:p>
+          <a:p>
+            <a:pPr>
+              <a:spcAft>
+                <a:spcPts val="400"/>
+              </a:spcAft>
+              <a:defRPr sz="1300">
+                <a:solidFill>
+                  <a:srgbClr val="FFFFFF"/>
+                </a:solidFill>
+                <a:latin typeface="Calibri"/>
+              </a:defRPr>
+            </a:pPr>
+            <a:r>
+              <a:t>• Progress Chart Tab:</a:t>
+            </a:r>
+          </a:p>
+          <a:p>
+            <a:pPr>
+              <a:spcAft>
+                <a:spcPts val="400"/>
+              </a:spcAft>
+              <a:defRPr sz="1300">
+                <a:solidFill>
+                  <a:srgbClr val="FFFFFF"/>
+                </a:solidFill>
+                <a:latin typeface="Calibri"/>
+              </a:defRPr>
+            </a:pPr>
+            <a:r>
+              <a:t>  - Recharts Area Chart plotting historical completion percentages over calendar snapshot dates.</a:t>
+            </a:r>
+          </a:p>
+          <a:p>
+            <a:pPr>
+              <a:spcAft>
+                <a:spcPts val="400"/>
+              </a:spcAft>
+              <a:defRPr sz="1300">
+                <a:solidFill>
+                  <a:srgbClr val="FFFFFF"/>
+                </a:solidFill>
+                <a:latin typeface="Calibri"/>
+              </a:defRPr>
+            </a:pPr>
+            <a:r>
+              <a:t>  - Highlighted 'Est. Completion' tag projecting final date based on progress velocity trends.</a:t>
             </a:r>
           </a:p>
         </p:txBody>
@@ -3904,7 +5191,7 @@
     <p:bg>
       <p:bgPr>
         <a:solidFill>
-          <a:srgbClr val="212121"/>
+          <a:srgbClr val="1E1E1E"/>
         </a:solidFill>
         <a:effectLst/>
       </p:bgPr>
@@ -3924,8 +5211,8 @@
         </p:nvSpPr>
         <p:spPr>
           <a:xfrm>
-            <a:off x="731520" y="548640"/>
-            <a:ext cx="10698480" cy="914400"/>
+            <a:off x="731520" y="365760"/>
+            <a:ext cx="10698480" cy="365760"/>
           </a:xfrm>
           <a:prstGeom prst="rect">
             <a:avLst/>
@@ -3933,21 +5220,21 @@
           <a:noFill/>
         </p:spPr>
         <p:txBody>
-          <a:bodyPr wrap="square">
+          <a:bodyPr wrap="none">
             <a:spAutoFit/>
           </a:bodyPr>
           <a:lstStyle/>
           <a:p>
             <a:pPr>
-              <a:defRPr sz="3600" b="1">
-                <a:solidFill>
-                  <a:srgbClr val="FFD54F"/>
-                </a:solidFill>
-                <a:latin typeface="Calibri"/>
-              </a:defRPr>
-            </a:pPr>
-            <a:r>
-              <a:t>5. Completion Estimation Models Compared</a:t>
+              <a:defRPr sz="1100" b="1">
+                <a:solidFill>
+                  <a:srgbClr val="F48FB1"/>
+                </a:solidFill>
+                <a:latin typeface="Calibri"/>
+              </a:defRPr>
+            </a:pPr>
+            <a:r>
+              <a:t>ROADMAP</a:t>
             </a:r>
           </a:p>
         </p:txBody>
@@ -3960,8 +5247,8 @@
         </p:nvSpPr>
         <p:spPr>
           <a:xfrm>
-            <a:off x="731520" y="1645920"/>
-            <a:ext cx="5120640" cy="4389120"/>
+            <a:off x="731520" y="548640"/>
+            <a:ext cx="10698480" cy="731520"/>
           </a:xfrm>
           <a:prstGeom prst="rect">
             <a:avLst/>
@@ -3969,16 +5256,13 @@
           <a:noFill/>
         </p:spPr>
         <p:txBody>
-          <a:bodyPr wrap="square">
+          <a:bodyPr wrap="none">
             <a:spAutoFit/>
           </a:bodyPr>
           <a:lstStyle/>
           <a:p>
             <a:pPr>
-              <a:spcAft>
-                <a:spcPts val="1200"/>
-              </a:spcAft>
-              <a:defRPr sz="2000" b="1">
+              <a:defRPr sz="3200" b="1">
                 <a:solidFill>
                   <a:srgbClr val="FFD54F"/>
                 </a:solidFill>
@@ -3986,79 +5270,169 @@
               </a:defRPr>
             </a:pPr>
             <a:r>
-              <a:t>Model A: Study Planner (Time-Based)</a:t>
-            </a:r>
-          </a:p>
-          <a:p>
-            <a:pPr>
-              <a:spcBef>
+              <a:t>Proposed Future Enhancements</a:t>
+            </a:r>
+          </a:p>
+        </p:txBody>
+      </p:sp>
+      <p:sp>
+        <p:nvSpPr>
+          <p:cNvPr id="4" name="Rounded Rectangle 3"/>
+          <p:cNvSpPr/>
+          <p:nvPr/>
+        </p:nvSpPr>
+        <p:spPr>
+          <a:xfrm>
+            <a:off x="731520" y="1645920"/>
+            <a:ext cx="5120640" cy="4389120"/>
+          </a:xfrm>
+          <a:prstGeom prst="roundRect">
+            <a:avLst/>
+          </a:prstGeom>
+          <a:solidFill>
+            <a:srgbClr val="2D2D2D"/>
+          </a:solidFill>
+          <a:ln w="19050">
+            <a:solidFill>
+              <a:srgbClr val="505050"/>
+            </a:solidFill>
+          </a:ln>
+        </p:spPr>
+        <p:style>
+          <a:lnRef idx="1">
+            <a:schemeClr val="accent1"/>
+          </a:lnRef>
+          <a:fillRef idx="3">
+            <a:schemeClr val="accent1"/>
+          </a:fillRef>
+          <a:effectRef idx="2">
+            <a:schemeClr val="accent1"/>
+          </a:effectRef>
+          <a:fontRef idx="minor">
+            <a:schemeClr val="lt1"/>
+          </a:fontRef>
+        </p:style>
+        <p:txBody>
+          <a:bodyPr rtlCol="0" anchor="ctr" wrap="square" lIns="137160" tIns="137160" rIns="137160" bIns="137160"/>
+          <a:lstStyle/>
+          <a:p>
+            <a:pPr algn="ctr">
+              <a:spcAft>
                 <a:spcPts val="800"/>
-              </a:spcBef>
-              <a:defRPr sz="1500">
-                <a:solidFill>
-                  <a:srgbClr val="FFFFFF"/>
-                </a:solidFill>
-                <a:latin typeface="Calibri"/>
-              </a:defRPr>
-            </a:pPr>
-            <a:r>
-              <a:t>• Focuses on total hours/duration of videos.</a:t>
-            </a:r>
-          </a:p>
-          <a:p>
-            <a:pPr>
-              <a:spcBef>
-                <a:spcPts val="800"/>
-              </a:spcBef>
-              <a:defRPr sz="1500">
-                <a:solidFill>
-                  <a:srgbClr val="FFFFFF"/>
-                </a:solidFill>
-                <a:latin typeface="Calibri"/>
-              </a:defRPr>
-            </a:pPr>
-            <a:r>
-              <a:t>• Calculates study speed in seconds/day: Actual completed duration divided by days since plan start.</a:t>
-            </a:r>
-          </a:p>
-          <a:p>
-            <a:pPr>
-              <a:spcBef>
-                <a:spcPts val="800"/>
-              </a:spcBef>
-              <a:defRPr sz="1500">
-                <a:solidFill>
-                  <a:srgbClr val="FFFFFF"/>
-                </a:solidFill>
-                <a:latin typeface="Calibri"/>
-              </a:defRPr>
-            </a:pPr>
-            <a:r>
-              <a:t>• Divides remaining video duration (hours) by this daily velocity to find remaining days.</a:t>
-            </a:r>
-          </a:p>
-          <a:p>
-            <a:pPr>
-              <a:spcBef>
-                <a:spcPts val="800"/>
-              </a:spcBef>
-              <a:defRPr sz="1500">
-                <a:solidFill>
-                  <a:srgbClr val="FFFFFF"/>
-                </a:solidFill>
-                <a:latin typeface="Calibri"/>
-              </a:defRPr>
-            </a:pPr>
-            <a:r>
-              <a:t>• Best for estimating based on remaining video load.</a:t>
-            </a:r>
-          </a:p>
-        </p:txBody>
-      </p:sp>
-      <p:sp>
-        <p:nvSpPr>
-          <p:cNvPr id="4" name="TextBox 3"/>
-          <p:cNvSpPr txBox="1"/>
+              </a:spcAft>
+              <a:defRPr sz="1600" b="1">
+                <a:solidFill>
+                  <a:srgbClr val="FFD54F"/>
+                </a:solidFill>
+                <a:latin typeface="Calibri"/>
+              </a:defRPr>
+            </a:pPr>
+            <a:r>
+              <a:t>⏰ Focused Learning &amp; Active Review</a:t>
+            </a:r>
+          </a:p>
+          <a:p>
+            <a:pPr>
+              <a:spcAft>
+                <a:spcPts val="400"/>
+              </a:spcAft>
+              <a:defRPr sz="1300">
+                <a:solidFill>
+                  <a:srgbClr val="FFFFFF"/>
+                </a:solidFill>
+                <a:latin typeface="Calibri"/>
+              </a:defRPr>
+            </a:pPr>
+            <a:r>
+              <a:t>• In-App Pomodoro Focus Timer:</a:t>
+            </a:r>
+          </a:p>
+          <a:p>
+            <a:pPr>
+              <a:spcAft>
+                <a:spcPts val="400"/>
+              </a:spcAft>
+              <a:defRPr sz="1300">
+                <a:solidFill>
+                  <a:srgbClr val="FFFFFF"/>
+                </a:solidFill>
+                <a:latin typeface="Calibri"/>
+              </a:defRPr>
+            </a:pPr>
+            <a:r>
+              <a:t>  - Integrate a customizable Pomodoro clock (25m study / 5m break) on the video workspace page.</a:t>
+            </a:r>
+          </a:p>
+          <a:p>
+            <a:pPr>
+              <a:spcAft>
+                <a:spcPts val="400"/>
+              </a:spcAft>
+              <a:defRPr sz="1300">
+                <a:solidFill>
+                  <a:srgbClr val="FFFFFF"/>
+                </a:solidFill>
+                <a:latin typeface="Calibri"/>
+              </a:defRPr>
+            </a:pPr>
+            <a:r>
+              <a:t>  - Automatically track and log the student's actual focus duration vs. expected video length.</a:t>
+            </a:r>
+          </a:p>
+          <a:p>
+            <a:pPr>
+              <a:spcAft>
+                <a:spcPts val="400"/>
+              </a:spcAft>
+              <a:defRPr sz="1300">
+                <a:solidFill>
+                  <a:srgbClr val="FFFFFF"/>
+                </a:solidFill>
+                <a:latin typeface="Calibri"/>
+              </a:defRPr>
+            </a:pPr>
+            <a:r>
+              <a:t>• Active Recall Quizzes &amp; Cards:</a:t>
+            </a:r>
+          </a:p>
+          <a:p>
+            <a:pPr>
+              <a:spcAft>
+                <a:spcPts val="400"/>
+              </a:spcAft>
+              <a:defRPr sz="1300">
+                <a:solidFill>
+                  <a:srgbClr val="FFFFFF"/>
+                </a:solidFill>
+                <a:latin typeface="Calibri"/>
+              </a:defRPr>
+            </a:pPr>
+            <a:r>
+              <a:t>  - Generate interactive flashcards from lecture metadata and student bookmark notes.</a:t>
+            </a:r>
+          </a:p>
+          <a:p>
+            <a:pPr>
+              <a:spcAft>
+                <a:spcPts val="400"/>
+              </a:spcAft>
+              <a:defRPr sz="1300">
+                <a:solidFill>
+                  <a:srgbClr val="FFFFFF"/>
+                </a:solidFill>
+                <a:latin typeface="Calibri"/>
+              </a:defRPr>
+            </a:pPr>
+            <a:r>
+              <a:t>  - Support Spaced Repetition Algorithms (like SuperMemo-2) to prompt student review schedules.</a:t>
+            </a:r>
+          </a:p>
+        </p:txBody>
+      </p:sp>
+      <p:sp>
+        <p:nvSpPr>
+          <p:cNvPr id="5" name="Rounded Rectangle 4"/>
+          <p:cNvSpPr/>
           <p:nvPr/>
         </p:nvSpPr>
         <p:spPr>
@@ -4066,94 +5440,161 @@
             <a:off x="6217920" y="1645920"/>
             <a:ext cx="5120640" cy="4389120"/>
           </a:xfrm>
-          <a:prstGeom prst="rect">
+          <a:prstGeom prst="roundRect">
             <a:avLst/>
           </a:prstGeom>
-          <a:noFill/>
+          <a:solidFill>
+            <a:srgbClr val="2D2D2D"/>
+          </a:solidFill>
+          <a:ln w="19050">
+            <a:solidFill>
+              <a:srgbClr val="505050"/>
+            </a:solidFill>
+          </a:ln>
         </p:spPr>
-        <p:txBody>
-          <a:bodyPr wrap="square">
-            <a:spAutoFit/>
-          </a:bodyPr>
-          <a:lstStyle/>
-          <a:p>
-            <a:pPr>
-              <a:spcAft>
-                <a:spcPts val="1200"/>
-              </a:spcAft>
-              <a:defRPr sz="2000" b="1">
-                <a:solidFill>
-                  <a:srgbClr val="F06292"/>
-                </a:solidFill>
-                <a:latin typeface="Calibri"/>
-              </a:defRPr>
-            </a:pPr>
-            <a:r>
-              <a:t>Model B: Progress Chart (Percentage-Based)</a:t>
-            </a:r>
-          </a:p>
-          <a:p>
-            <a:pPr>
-              <a:spcBef>
+        <p:style>
+          <a:lnRef idx="1">
+            <a:schemeClr val="accent1"/>
+          </a:lnRef>
+          <a:fillRef idx="3">
+            <a:schemeClr val="accent1"/>
+          </a:fillRef>
+          <a:effectRef idx="2">
+            <a:schemeClr val="accent1"/>
+          </a:effectRef>
+          <a:fontRef idx="minor">
+            <a:schemeClr val="lt1"/>
+          </a:fontRef>
+        </p:style>
+        <p:txBody>
+          <a:bodyPr rtlCol="0" anchor="ctr" wrap="square" lIns="137160" tIns="137160" rIns="137160" bIns="137160"/>
+          <a:lstStyle/>
+          <a:p>
+            <a:pPr algn="ctr">
+              <a:spcAft>
                 <a:spcPts val="800"/>
-              </a:spcBef>
-              <a:defRPr sz="1500">
-                <a:solidFill>
-                  <a:srgbClr val="FFFFFF"/>
-                </a:solidFill>
-                <a:latin typeface="Calibri"/>
-              </a:defRPr>
-            </a:pPr>
-            <a:r>
-              <a:t>• Focuses on completed lecture counts (%).</a:t>
-            </a:r>
-          </a:p>
-          <a:p>
-            <a:pPr>
-              <a:spcBef>
-                <a:spcPts val="800"/>
-              </a:spcBef>
-              <a:defRPr sz="1500">
-                <a:solidFill>
-                  <a:srgbClr val="FFFFFF"/>
-                </a:solidFill>
-                <a:latin typeface="Calibri"/>
-              </a:defRPr>
-            </a:pPr>
-            <a:r>
-              <a:t>• Calculates daily progress velocity over the last 7 days of completion snapshots.</a:t>
-            </a:r>
-          </a:p>
-          <a:p>
-            <a:pPr>
-              <a:spcBef>
-                <a:spcPts val="800"/>
-              </a:spcBef>
-              <a:defRPr sz="1500">
-                <a:solidFill>
-                  <a:srgbClr val="FFFFFF"/>
-                </a:solidFill>
-                <a:latin typeface="Calibri"/>
-              </a:defRPr>
-            </a:pPr>
-            <a:r>
-              <a:t>• Divides remaining progress percentage (100% - current%) by daily percentage velocity.</a:t>
-            </a:r>
-          </a:p>
-          <a:p>
-            <a:pPr>
-              <a:spcBef>
-                <a:spcPts val="800"/>
-              </a:spcBef>
-              <a:defRPr sz="1500">
-                <a:solidFill>
-                  <a:srgbClr val="FFFFFF"/>
-                </a:solidFill>
-                <a:latin typeface="Calibri"/>
-              </a:defRPr>
-            </a:pPr>
-            <a:r>
-              <a:t>• Best for estimating based on historical daily consistency.</a:t>
+              </a:spcAft>
+              <a:defRPr sz="1600" b="1">
+                <a:solidFill>
+                  <a:srgbClr val="F48FB1"/>
+                </a:solidFill>
+                <a:latin typeface="Calibri"/>
+              </a:defRPr>
+            </a:pPr>
+            <a:r>
+              <a:t>🔌 Multi-Source &amp; Platform Growth</a:t>
+            </a:r>
+          </a:p>
+          <a:p>
+            <a:pPr>
+              <a:spcAft>
+                <a:spcPts val="400"/>
+              </a:spcAft>
+              <a:defRPr sz="1300">
+                <a:solidFill>
+                  <a:srgbClr val="FFFFFF"/>
+                </a:solidFill>
+                <a:latin typeface="Calibri"/>
+              </a:defRPr>
+            </a:pPr>
+            <a:r>
+              <a:t>• Multi-Source Courseware Importers:</a:t>
+            </a:r>
+          </a:p>
+          <a:p>
+            <a:pPr>
+              <a:spcAft>
+                <a:spcPts val="400"/>
+              </a:spcAft>
+              <a:defRPr sz="1300">
+                <a:solidFill>
+                  <a:srgbClr val="FFFFFF"/>
+                </a:solidFill>
+                <a:latin typeface="Calibri"/>
+              </a:defRPr>
+            </a:pPr>
+            <a:r>
+              <a:t>  - Extend import pipelines to handle Coursera, Udemy, local PDFs, textbooks, and slide decks.</a:t>
+            </a:r>
+          </a:p>
+          <a:p>
+            <a:pPr>
+              <a:spcAft>
+                <a:spcPts val="400"/>
+              </a:spcAft>
+              <a:defRPr sz="1300">
+                <a:solidFill>
+                  <a:srgbClr val="FFFFFF"/>
+                </a:solidFill>
+                <a:latin typeface="Calibri"/>
+              </a:defRPr>
+            </a:pPr>
+            <a:r>
+              <a:t>• Mobile App &amp; Push Notifications (PWA):</a:t>
+            </a:r>
+          </a:p>
+          <a:p>
+            <a:pPr>
+              <a:spcAft>
+                <a:spcPts val="400"/>
+              </a:spcAft>
+              <a:defRPr sz="1300">
+                <a:solidFill>
+                  <a:srgbClr val="FFFFFF"/>
+                </a:solidFill>
+                <a:latin typeface="Calibri"/>
+              </a:defRPr>
+            </a:pPr>
+            <a:r>
+              <a:t>  - Enable Progressive Web App support for study tracking on tablets and mobile phones.</a:t>
+            </a:r>
+          </a:p>
+          <a:p>
+            <a:pPr>
+              <a:spcAft>
+                <a:spcPts val="400"/>
+              </a:spcAft>
+              <a:defRPr sz="1300">
+                <a:solidFill>
+                  <a:srgbClr val="FFFFFF"/>
+                </a:solidFill>
+                <a:latin typeface="Calibri"/>
+              </a:defRPr>
+            </a:pPr>
+            <a:r>
+              <a:t>  - Set up push alerts reminding students of their daily study targets and rollover times.</a:t>
+            </a:r>
+          </a:p>
+          <a:p>
+            <a:pPr>
+              <a:spcAft>
+                <a:spcPts val="400"/>
+              </a:spcAft>
+              <a:defRPr sz="1300">
+                <a:solidFill>
+                  <a:srgbClr val="FFFFFF"/>
+                </a:solidFill>
+                <a:latin typeface="Calibri"/>
+              </a:defRPr>
+            </a:pPr>
+            <a:r>
+              <a:t>• Social Gamification Streaks:</a:t>
+            </a:r>
+          </a:p>
+          <a:p>
+            <a:pPr>
+              <a:spcAft>
+                <a:spcPts val="400"/>
+              </a:spcAft>
+              <a:defRPr sz="1300">
+                <a:solidFill>
+                  <a:srgbClr val="FFFFFF"/>
+                </a:solidFill>
+                <a:latin typeface="Calibri"/>
+              </a:defRPr>
+            </a:pPr>
+            <a:r>
+              <a:t>  - Reward study habits with streaks, experience points (XP), level-ups, and badges.</a:t>
             </a:r>
           </a:p>
         </p:txBody>
@@ -4172,7 +5613,7 @@
     <p:bg>
       <p:bgPr>
         <a:solidFill>
-          <a:srgbClr val="212121"/>
+          <a:srgbClr val="1E1E1E"/>
         </a:solidFill>
         <a:effectLst/>
       </p:bgPr>
@@ -4192,8 +5633,8 @@
         </p:nvSpPr>
         <p:spPr>
           <a:xfrm>
-            <a:off x="731520" y="548640"/>
-            <a:ext cx="10698480" cy="914400"/>
+            <a:off x="731520" y="365760"/>
+            <a:ext cx="10698480" cy="365760"/>
           </a:xfrm>
           <a:prstGeom prst="rect">
             <a:avLst/>
@@ -4201,21 +5642,21 @@
           <a:noFill/>
         </p:spPr>
         <p:txBody>
-          <a:bodyPr wrap="square">
+          <a:bodyPr wrap="none">
             <a:spAutoFit/>
           </a:bodyPr>
           <a:lstStyle/>
           <a:p>
             <a:pPr>
-              <a:defRPr sz="3600" b="1">
-                <a:solidFill>
-                  <a:srgbClr val="FFD54F"/>
-                </a:solidFill>
-                <a:latin typeface="Calibri"/>
-              </a:defRPr>
-            </a:pPr>
-            <a:r>
-              <a:t>6. Embedded YouTube Player &amp; Bookmark System</a:t>
+              <a:defRPr sz="1100" b="1">
+                <a:solidFill>
+                  <a:srgbClr val="F48FB1"/>
+                </a:solidFill>
+                <a:latin typeface="Calibri"/>
+              </a:defRPr>
+            </a:pPr>
+            <a:r>
+              <a:t>UNDER THE HOOD</a:t>
             </a:r>
           </a:p>
         </p:txBody>
@@ -4228,8 +5669,8 @@
         </p:nvSpPr>
         <p:spPr>
           <a:xfrm>
-            <a:off x="731520" y="1645920"/>
-            <a:ext cx="10698480" cy="4572000"/>
+            <a:off x="731520" y="548640"/>
+            <a:ext cx="10698480" cy="731520"/>
           </a:xfrm>
           <a:prstGeom prst="rect">
             <a:avLst/>
@@ -4237,17 +5678,13 @@
           <a:noFill/>
         </p:spPr>
         <p:txBody>
-          <a:bodyPr wrap="square">
+          <a:bodyPr wrap="none">
             <a:spAutoFit/>
           </a:bodyPr>
           <a:lstStyle/>
-          <a:p/>
-          <a:p>
-            <a:pPr>
-              <a:spcAft>
-                <a:spcPts val="2000"/>
-              </a:spcAft>
-              <a:defRPr sz="1800" b="1">
+          <a:p>
+            <a:pPr>
+              <a:defRPr sz="3200" b="1">
                 <a:solidFill>
                   <a:srgbClr val="FFD54F"/>
                 </a:solidFill>
@@ -4255,91 +5692,347 @@
               </a:defRPr>
             </a:pPr>
             <a:r>
-              <a:t>• YouTube Iframe API Integration: </a:t>
-            </a:r>
-            <a:r>
-              <a:rPr sz="1600" b="0">
-                <a:solidFill>
-                  <a:srgbClr val="FFFFFF"/>
-                </a:solidFill>
-                <a:latin typeface="Calibri"/>
-              </a:rPr>
-              <a:t>Binds a standard iframe with `enablejsapi=1` to the official SDK, capturing full playback control without third-party wrapper overhead.</a:t>
-            </a:r>
-          </a:p>
-          <a:p>
-            <a:pPr>
-              <a:spcAft>
-                <a:spcPts val="2000"/>
-              </a:spcAft>
-              <a:defRPr sz="1800" b="1">
-                <a:solidFill>
-                  <a:srgbClr val="FFD54F"/>
-                </a:solidFill>
-                <a:latin typeface="Calibri"/>
-              </a:defRPr>
-            </a:pPr>
-            <a:r>
-              <a:t>• One-Click Timestamp Capturing: </a:t>
-            </a:r>
-            <a:r>
-              <a:rPr sz="1600" b="0">
-                <a:solidFill>
-                  <a:srgbClr val="FFFFFF"/>
-                </a:solidFill>
-                <a:latin typeface="Calibri"/>
-              </a:rPr>
-              <a:t>When the user adds a note, the system queries the player in real-time (`player.getCurrentTime()`) and pins the note to that exact timestamp.</a:t>
-            </a:r>
-          </a:p>
-          <a:p>
-            <a:pPr>
-              <a:spcAft>
-                <a:spcPts val="2000"/>
-              </a:spcAft>
-              <a:defRPr sz="1800" b="1">
-                <a:solidFill>
-                  <a:srgbClr val="FFD54F"/>
-                </a:solidFill>
-                <a:latin typeface="Calibri"/>
-              </a:defRPr>
-            </a:pPr>
-            <a:r>
-              <a:t>• Instant Player Seeking: </a:t>
-            </a:r>
-            <a:r>
-              <a:rPr sz="1600" b="0">
-                <a:solidFill>
-                  <a:srgbClr val="FFFFFF"/>
-                </a:solidFill>
-                <a:latin typeface="Calibri"/>
-              </a:rPr>
-              <a:t>Clicking a saved bookmark button triggers `player.seekTo(seconds, True)` to jump the video directly to the pinned moment smoothly.</a:t>
-            </a:r>
-          </a:p>
-          <a:p>
-            <a:pPr>
-              <a:spcAft>
-                <a:spcPts val="2000"/>
-              </a:spcAft>
-              <a:defRPr sz="1800" b="1">
-                <a:solidFill>
-                  <a:srgbClr val="FFD54F"/>
-                </a:solidFill>
-                <a:latin typeface="Calibri"/>
-              </a:defRPr>
-            </a:pPr>
-            <a:r>
-              <a:t>• Relational Storage &amp; Security: </a:t>
-            </a:r>
-            <a:r>
-              <a:rPr sz="1600" b="0">
-                <a:solidFill>
-                  <a:srgbClr val="FFFFFF"/>
-                </a:solidFill>
-                <a:latin typeface="Calibri"/>
-              </a:rPr>
-              <a:t>Bookmarks are saved in the `lecture_bookmarks` table and secured via owner-verification logic in the backend router.</a:t>
+              <a:t>Technical Execution &amp; Internal Workings</a:t>
+            </a:r>
+          </a:p>
+        </p:txBody>
+      </p:sp>
+      <p:sp>
+        <p:nvSpPr>
+          <p:cNvPr id="4" name="Rounded Rectangle 3"/>
+          <p:cNvSpPr/>
+          <p:nvPr/>
+        </p:nvSpPr>
+        <p:spPr>
+          <a:xfrm>
+            <a:off x="731520" y="1645920"/>
+            <a:ext cx="5120640" cy="4389120"/>
+          </a:xfrm>
+          <a:prstGeom prst="roundRect">
+            <a:avLst/>
+          </a:prstGeom>
+          <a:solidFill>
+            <a:srgbClr val="2D2D2D"/>
+          </a:solidFill>
+          <a:ln w="19050">
+            <a:solidFill>
+              <a:srgbClr val="505050"/>
+            </a:solidFill>
+          </a:ln>
+        </p:spPr>
+        <p:style>
+          <a:lnRef idx="1">
+            <a:schemeClr val="accent1"/>
+          </a:lnRef>
+          <a:fillRef idx="3">
+            <a:schemeClr val="accent1"/>
+          </a:fillRef>
+          <a:effectRef idx="2">
+            <a:schemeClr val="accent1"/>
+          </a:effectRef>
+          <a:fontRef idx="minor">
+            <a:schemeClr val="lt1"/>
+          </a:fontRef>
+        </p:style>
+        <p:txBody>
+          <a:bodyPr rtlCol="0" anchor="ctr" wrap="square" lIns="137160" tIns="137160" rIns="137160" bIns="137160"/>
+          <a:lstStyle/>
+          <a:p>
+            <a:pPr algn="ctr">
+              <a:spcAft>
+                <a:spcPts val="800"/>
+              </a:spcAft>
+              <a:defRPr sz="1600" b="1">
+                <a:solidFill>
+                  <a:srgbClr val="81D4FA"/>
+                </a:solidFill>
+                <a:latin typeface="Calibri"/>
+              </a:defRPr>
+            </a:pPr>
+            <a:r>
+              <a:t>⚙️ Importer &amp; Duration Processing</a:t>
+            </a:r>
+          </a:p>
+          <a:p>
+            <a:pPr>
+              <a:spcAft>
+                <a:spcPts val="400"/>
+              </a:spcAft>
+              <a:defRPr sz="1300">
+                <a:solidFill>
+                  <a:srgbClr val="FFFFFF"/>
+                </a:solidFill>
+                <a:latin typeface="Calibri"/>
+              </a:defRPr>
+            </a:pPr>
+            <a:r>
+              <a:t>• Batch API Ingestion:</a:t>
+            </a:r>
+          </a:p>
+          <a:p>
+            <a:pPr>
+              <a:spcAft>
+                <a:spcPts val="400"/>
+              </a:spcAft>
+              <a:defRPr sz="1300">
+                <a:solidFill>
+                  <a:srgbClr val="FFFFFF"/>
+                </a:solidFill>
+                <a:latin typeface="Calibri"/>
+              </a:defRPr>
+            </a:pPr>
+            <a:r>
+              <a:t>  - YouTube API v3 chunking: IDs are requested in groups of 50 via the /videos endpoint. This reduces HTTP request overhead and saves API quota.</a:t>
+            </a:r>
+          </a:p>
+          <a:p>
+            <a:pPr>
+              <a:spcAft>
+                <a:spcPts val="400"/>
+              </a:spcAft>
+              <a:defRPr sz="1300">
+                <a:solidFill>
+                  <a:srgbClr val="FFFFFF"/>
+                </a:solidFill>
+                <a:latin typeface="Calibri"/>
+              </a:defRPr>
+            </a:pPr>
+            <a:r>
+              <a:t>• ISO-8601 Duration Parser:</a:t>
+            </a:r>
+          </a:p>
+          <a:p>
+            <a:pPr>
+              <a:spcAft>
+                <a:spcPts val="400"/>
+              </a:spcAft>
+              <a:defRPr sz="1300">
+                <a:solidFill>
+                  <a:srgbClr val="FFFFFF"/>
+                </a:solidFill>
+                <a:latin typeface="Calibri"/>
+              </a:defRPr>
+            </a:pPr>
+            <a:r>
+              <a:t>  - Regex-based duration translation parses ISO strings directly into total seconds: `h * 3600 + m * 60 + s`.</a:t>
+            </a:r>
+          </a:p>
+          <a:p>
+            <a:pPr>
+              <a:spcAft>
+                <a:spcPts val="400"/>
+              </a:spcAft>
+              <a:defRPr sz="1300">
+                <a:solidFill>
+                  <a:srgbClr val="FFFFFF"/>
+                </a:solidFill>
+                <a:latin typeface="Calibri"/>
+              </a:defRPr>
+            </a:pPr>
+            <a:r>
+              <a:t>• Timezone-Agnostic Rollover Boundary:</a:t>
+            </a:r>
+          </a:p>
+          <a:p>
+            <a:pPr>
+              <a:spcAft>
+                <a:spcPts val="400"/>
+              </a:spcAft>
+              <a:defRPr sz="1300">
+                <a:solidFill>
+                  <a:srgbClr val="FFFFFF"/>
+                </a:solidFill>
+                <a:latin typeface="Calibri"/>
+              </a:defRPr>
+            </a:pPr>
+            <a:r>
+              <a:t>  - Normalizes today's local date and plan start date to 12:00 AM local midnight. This ensures day counts increment exactly at midnight, independent of study hours or UTC offsets.</a:t>
+            </a:r>
+          </a:p>
+        </p:txBody>
+      </p:sp>
+      <p:sp>
+        <p:nvSpPr>
+          <p:cNvPr id="5" name="Rounded Rectangle 4"/>
+          <p:cNvSpPr/>
+          <p:nvPr/>
+        </p:nvSpPr>
+        <p:spPr>
+          <a:xfrm>
+            <a:off x="6217920" y="1645920"/>
+            <a:ext cx="5120640" cy="4389120"/>
+          </a:xfrm>
+          <a:prstGeom prst="roundRect">
+            <a:avLst/>
+          </a:prstGeom>
+          <a:solidFill>
+            <a:srgbClr val="2D2D2D"/>
+          </a:solidFill>
+          <a:ln w="19050">
+            <a:solidFill>
+              <a:srgbClr val="505050"/>
+            </a:solidFill>
+          </a:ln>
+        </p:spPr>
+        <p:style>
+          <a:lnRef idx="1">
+            <a:schemeClr val="accent1"/>
+          </a:lnRef>
+          <a:fillRef idx="3">
+            <a:schemeClr val="accent1"/>
+          </a:fillRef>
+          <a:effectRef idx="2">
+            <a:schemeClr val="accent1"/>
+          </a:effectRef>
+          <a:fontRef idx="minor">
+            <a:schemeClr val="lt1"/>
+          </a:fontRef>
+        </p:style>
+        <p:txBody>
+          <a:bodyPr rtlCol="0" anchor="ctr" wrap="square" lIns="137160" tIns="137160" rIns="137160" bIns="137160"/>
+          <a:lstStyle/>
+          <a:p>
+            <a:pPr algn="ctr">
+              <a:spcAft>
+                <a:spcPts val="800"/>
+              </a:spcAft>
+              <a:defRPr sz="1600" b="1">
+                <a:solidFill>
+                  <a:srgbClr val="F48FB1"/>
+                </a:solidFill>
+                <a:latin typeface="Calibri"/>
+              </a:defRPr>
+            </a:pPr>
+            <a:r>
+              <a:t>📊 Study Planner Calculations</a:t>
+            </a:r>
+          </a:p>
+          <a:p>
+            <a:pPr>
+              <a:spcAft>
+                <a:spcPts val="400"/>
+              </a:spcAft>
+              <a:defRPr sz="1300">
+                <a:solidFill>
+                  <a:srgbClr val="FFFFFF"/>
+                </a:solidFill>
+                <a:latin typeface="Calibri"/>
+              </a:defRPr>
+            </a:pPr>
+            <a:r>
+              <a:t>• Hours-per-day Greedy Allocation:</a:t>
+            </a:r>
+          </a:p>
+          <a:p>
+            <a:pPr>
+              <a:spcAft>
+                <a:spcPts val="400"/>
+              </a:spcAft>
+              <a:defRPr sz="1300">
+                <a:solidFill>
+                  <a:srgbClr val="FFFFFF"/>
+                </a:solidFill>
+                <a:latin typeface="Calibri"/>
+              </a:defRPr>
+            </a:pPr>
+            <a:r>
+              <a:t>  - Packs lectures sequentially into days. Checks: `current_duration + lecture.duration &lt;= max_seconds_per_day`.</a:t>
+            </a:r>
+          </a:p>
+          <a:p>
+            <a:pPr>
+              <a:spcAft>
+                <a:spcPts val="400"/>
+              </a:spcAft>
+              <a:defRPr sz="1300">
+                <a:solidFill>
+                  <a:srgbClr val="FFFFFF"/>
+                </a:solidFill>
+                <a:latin typeface="Calibri"/>
+              </a:defRPr>
+            </a:pPr>
+            <a:r>
+              <a:t>• Days-count Average Partitioning:</a:t>
+            </a:r>
+          </a:p>
+          <a:p>
+            <a:pPr>
+              <a:spcAft>
+                <a:spcPts val="400"/>
+              </a:spcAft>
+              <a:defRPr sz="1300">
+                <a:solidFill>
+                  <a:srgbClr val="FFFFFF"/>
+                </a:solidFill>
+                <a:latin typeface="Calibri"/>
+              </a:defRPr>
+            </a:pPr>
+            <a:r>
+              <a:t>  - Calculates target average load: `total_duration / target_days`.</a:t>
+            </a:r>
+          </a:p>
+          <a:p>
+            <a:pPr>
+              <a:spcAft>
+                <a:spcPts val="400"/>
+              </a:spcAft>
+              <a:defRPr sz="1300">
+                <a:solidFill>
+                  <a:srgbClr val="FFFFFF"/>
+                </a:solidFill>
+                <a:latin typeface="Calibri"/>
+              </a:defRPr>
+            </a:pPr>
+            <a:r>
+              <a:t>  - Finds optimal partition indices where cumulative sums are closest to multiples of the daily target average.</a:t>
+            </a:r>
+          </a:p>
+          <a:p>
+            <a:pPr>
+              <a:spcAft>
+                <a:spcPts val="400"/>
+              </a:spcAft>
+              <a:defRPr sz="1300">
+                <a:solidFill>
+                  <a:srgbClr val="FFFFFF"/>
+                </a:solidFill>
+                <a:latin typeface="Calibri"/>
+              </a:defRPr>
+            </a:pPr>
+            <a:r>
+              <a:t>• Date estimation velocity formula:</a:t>
+            </a:r>
+          </a:p>
+          <a:p>
+            <a:pPr>
+              <a:spcAft>
+                <a:spcPts val="400"/>
+              </a:spcAft>
+              <a:defRPr sz="1300">
+                <a:solidFill>
+                  <a:srgbClr val="FFFFFF"/>
+                </a:solidFill>
+                <a:latin typeface="Calibri"/>
+              </a:defRPr>
+            </a:pPr>
+            <a:r>
+              <a:t>  - planner_velocity = completed_duration / days_passed.</a:t>
+            </a:r>
+          </a:p>
+          <a:p>
+            <a:pPr>
+              <a:spcAft>
+                <a:spcPts val="400"/>
+              </a:spcAft>
+              <a:defRPr sz="1300">
+                <a:solidFill>
+                  <a:srgbClr val="FFFFFF"/>
+                </a:solidFill>
+                <a:latin typeface="Calibri"/>
+              </a:defRPr>
+            </a:pPr>
+            <a:r>
+              <a:t>  - remaining_days = remaining_duration / planner_velocity.</a:t>
             </a:r>
           </a:p>
         </p:txBody>
@@ -4358,7 +6051,7 @@
     <p:bg>
       <p:bgPr>
         <a:solidFill>
-          <a:srgbClr val="212121"/>
+          <a:srgbClr val="1E1E1E"/>
         </a:solidFill>
         <a:effectLst/>
       </p:bgPr>
@@ -4378,8 +6071,8 @@
         </p:nvSpPr>
         <p:spPr>
           <a:xfrm>
-            <a:off x="731520" y="548640"/>
-            <a:ext cx="10698480" cy="914400"/>
+            <a:off x="731520" y="365760"/>
+            <a:ext cx="10698480" cy="365760"/>
           </a:xfrm>
           <a:prstGeom prst="rect">
             <a:avLst/>
@@ -4387,21 +6080,21 @@
           <a:noFill/>
         </p:spPr>
         <p:txBody>
-          <a:bodyPr wrap="square">
+          <a:bodyPr wrap="none">
             <a:spAutoFit/>
           </a:bodyPr>
           <a:lstStyle/>
           <a:p>
             <a:pPr>
-              <a:defRPr sz="3600" b="1">
-                <a:solidFill>
-                  <a:srgbClr val="FFD54F"/>
-                </a:solidFill>
-                <a:latin typeface="Calibri"/>
-              </a:defRPr>
-            </a:pPr>
-            <a:r>
-              <a:t>7. AI Tutor Integration &amp; Token Safeguards</a:t>
+              <a:defRPr sz="1100" b="1">
+                <a:solidFill>
+                  <a:srgbClr val="F48FB1"/>
+                </a:solidFill>
+                <a:latin typeface="Calibri"/>
+              </a:defRPr>
+            </a:pPr>
+            <a:r>
+              <a:t>STUDENT LIFECYCLE</a:t>
             </a:r>
           </a:p>
         </p:txBody>
@@ -4414,8 +6107,8 @@
         </p:nvSpPr>
         <p:spPr>
           <a:xfrm>
-            <a:off x="731520" y="1645920"/>
-            <a:ext cx="10698480" cy="4572000"/>
+            <a:off x="731520" y="548640"/>
+            <a:ext cx="10698480" cy="731520"/>
           </a:xfrm>
           <a:prstGeom prst="rect">
             <a:avLst/>
@@ -4423,109 +6116,465 @@
           <a:noFill/>
         </p:spPr>
         <p:txBody>
-          <a:bodyPr wrap="square">
+          <a:bodyPr wrap="none">
             <a:spAutoFit/>
           </a:bodyPr>
           <a:lstStyle/>
-          <a:p/>
-          <a:p>
-            <a:pPr>
-              <a:spcAft>
-                <a:spcPts val="2000"/>
-              </a:spcAft>
-              <a:defRPr sz="1800" b="1">
-                <a:solidFill>
-                  <a:srgbClr val="4FC3F7"/>
-                </a:solidFill>
-                <a:latin typeface="Calibri"/>
-              </a:defRPr>
-            </a:pPr>
-            <a:r>
-              <a:t>• Contextual AI Chat: </a:t>
-            </a:r>
-            <a:r>
-              <a:rPr sz="1600" b="0">
-                <a:solidFill>
-                  <a:srgbClr val="FFFFFF"/>
-                </a:solidFill>
-                <a:latin typeface="Calibri"/>
-              </a:rPr>
-              <a:t>Initializes Gemini with system instructions that lock the model's knowledge context strictly to the subject's video transcripts.</a:t>
-            </a:r>
-          </a:p>
-          <a:p>
-            <a:pPr>
-              <a:spcAft>
-                <a:spcPts val="2000"/>
-              </a:spcAft>
-              <a:defRPr sz="1800" b="1">
-                <a:solidFill>
-                  <a:srgbClr val="4FC3F7"/>
-                </a:solidFill>
-                <a:latin typeface="Calibri"/>
-              </a:defRPr>
-            </a:pPr>
-            <a:r>
-              <a:t>• Multi-Prompt Note Generator: </a:t>
-            </a:r>
-            <a:r>
-              <a:rPr sz="1600" b="0">
-                <a:solidFill>
-                  <a:srgbClr val="FFFFFF"/>
-                </a:solidFill>
-                <a:latin typeface="Calibri"/>
-              </a:rPr>
-              <a:t>Generates tailored Study Materials (Comprehensive Notes, Cheat Sheets, or Q&amp;A Question Sets) directly from transcript assets.</a:t>
-            </a:r>
-          </a:p>
-          <a:p>
-            <a:pPr>
-              <a:spcAft>
-                <a:spcPts val="2000"/>
-              </a:spcAft>
-              <a:defRPr sz="1800" b="1">
-                <a:solidFill>
-                  <a:srgbClr val="4FC3F7"/>
-                </a:solidFill>
-                <a:latin typeface="Calibri"/>
-              </a:defRPr>
-            </a:pPr>
-            <a:r>
-              <a:t>• Free-Tier Token Guardrail: </a:t>
-            </a:r>
-            <a:r>
-              <a:rPr sz="1600" b="0">
-                <a:solidFill>
-                  <a:srgbClr val="FFFFFF"/>
-                </a:solidFill>
-                <a:latin typeface="Calibri"/>
-              </a:rPr>
-              <a:t>Scans transcript sizes and truncates content if they exceed ~100k tokens to guarantee zero 429 Rate Limit blockages from Google AI Studio.</a:t>
-            </a:r>
-          </a:p>
-          <a:p>
-            <a:pPr>
-              <a:spcAft>
-                <a:spcPts val="2000"/>
-              </a:spcAft>
-              <a:defRPr sz="1800" b="1">
-                <a:solidFill>
-                  <a:srgbClr val="4FC3F7"/>
-                </a:solidFill>
-                <a:latin typeface="Calibri"/>
-              </a:defRPr>
-            </a:pPr>
-            <a:r>
-              <a:t>• Real-time State Synchronization: </a:t>
-            </a:r>
-            <a:r>
-              <a:rPr sz="1600" b="0">
-                <a:solidFill>
-                  <a:srgbClr val="FFFFFF"/>
-                </a:solidFill>
-                <a:latin typeface="Calibri"/>
-              </a:rPr>
-              <a:t>Subjects, progress charts, and daily planner widgets update instantly upon playlist imports or checkbox checks with zero manual page refreshes.</a:t>
+          <a:p>
+            <a:pPr>
+              <a:defRPr sz="3200" b="1">
+                <a:solidFill>
+                  <a:srgbClr val="FFD54F"/>
+                </a:solidFill>
+                <a:latin typeface="Calibri"/>
+              </a:defRPr>
+            </a:pPr>
+            <a:r>
+              <a:t>Student User Flow Diagram &amp; Lifecycle States</a:t>
+            </a:r>
+          </a:p>
+        </p:txBody>
+      </p:sp>
+      <p:sp>
+        <p:nvSpPr>
+          <p:cNvPr id="4" name="Rounded Rectangle 3"/>
+          <p:cNvSpPr/>
+          <p:nvPr/>
+        </p:nvSpPr>
+        <p:spPr>
+          <a:xfrm>
+            <a:off x="731520" y="1828800"/>
+            <a:ext cx="3291840" cy="1645920"/>
+          </a:xfrm>
+          <a:prstGeom prst="roundRect">
+            <a:avLst/>
+          </a:prstGeom>
+          <a:solidFill>
+            <a:srgbClr val="2D2D2D"/>
+          </a:solidFill>
+          <a:ln w="19050">
+            <a:solidFill>
+              <a:srgbClr val="505050"/>
+            </a:solidFill>
+          </a:ln>
+        </p:spPr>
+        <p:style>
+          <a:lnRef idx="1">
+            <a:schemeClr val="accent1"/>
+          </a:lnRef>
+          <a:fillRef idx="3">
+            <a:schemeClr val="accent1"/>
+          </a:fillRef>
+          <a:effectRef idx="2">
+            <a:schemeClr val="accent1"/>
+          </a:effectRef>
+          <a:fontRef idx="minor">
+            <a:schemeClr val="lt1"/>
+          </a:fontRef>
+        </p:style>
+        <p:txBody>
+          <a:bodyPr rtlCol="0" anchor="ctr" wrap="square" lIns="137160" tIns="137160" rIns="137160" bIns="137160"/>
+          <a:lstStyle/>
+          <a:p>
+            <a:pPr algn="ctr">
+              <a:spcAft>
+                <a:spcPts val="800"/>
+              </a:spcAft>
+              <a:defRPr sz="1600" b="1">
+                <a:solidFill>
+                  <a:srgbClr val="81D4FA"/>
+                </a:solidFill>
+                <a:latin typeface="Calibri"/>
+              </a:defRPr>
+            </a:pPr>
+            <a:r>
+              <a:t>1. Create Subject</a:t>
+            </a:r>
+          </a:p>
+          <a:p>
+            <a:pPr>
+              <a:spcAft>
+                <a:spcPts val="400"/>
+              </a:spcAft>
+              <a:defRPr sz="1300">
+                <a:solidFill>
+                  <a:srgbClr val="FFFFFF"/>
+                </a:solidFill>
+                <a:latin typeface="Calibri"/>
+              </a:defRPr>
+            </a:pPr>
+            <a:r>
+              <a:t>Register &amp; create a course card on dashboard</a:t>
+            </a:r>
+          </a:p>
+        </p:txBody>
+      </p:sp>
+      <p:sp>
+        <p:nvSpPr>
+          <p:cNvPr id="5" name="Rounded Rectangle 4"/>
+          <p:cNvSpPr/>
+          <p:nvPr/>
+        </p:nvSpPr>
+        <p:spPr>
+          <a:xfrm>
+            <a:off x="4389120" y="1828800"/>
+            <a:ext cx="3291840" cy="1645920"/>
+          </a:xfrm>
+          <a:prstGeom prst="roundRect">
+            <a:avLst/>
+          </a:prstGeom>
+          <a:solidFill>
+            <a:srgbClr val="2D2D2D"/>
+          </a:solidFill>
+          <a:ln w="19050">
+            <a:solidFill>
+              <a:srgbClr val="505050"/>
+            </a:solidFill>
+          </a:ln>
+        </p:spPr>
+        <p:style>
+          <a:lnRef idx="1">
+            <a:schemeClr val="accent1"/>
+          </a:lnRef>
+          <a:fillRef idx="3">
+            <a:schemeClr val="accent1"/>
+          </a:fillRef>
+          <a:effectRef idx="2">
+            <a:schemeClr val="accent1"/>
+          </a:effectRef>
+          <a:fontRef idx="minor">
+            <a:schemeClr val="lt1"/>
+          </a:fontRef>
+        </p:style>
+        <p:txBody>
+          <a:bodyPr rtlCol="0" anchor="ctr" wrap="square" lIns="137160" tIns="137160" rIns="137160" bIns="137160"/>
+          <a:lstStyle/>
+          <a:p>
+            <a:pPr algn="ctr">
+              <a:spcAft>
+                <a:spcPts val="800"/>
+              </a:spcAft>
+              <a:defRPr sz="1600" b="1">
+                <a:solidFill>
+                  <a:srgbClr val="81D4FA"/>
+                </a:solidFill>
+                <a:latin typeface="Calibri"/>
+              </a:defRPr>
+            </a:pPr>
+            <a:r>
+              <a:t>2. Batch Import</a:t>
+            </a:r>
+          </a:p>
+          <a:p>
+            <a:pPr>
+              <a:spcAft>
+                <a:spcPts val="400"/>
+              </a:spcAft>
+              <a:defRPr sz="1300">
+                <a:solidFill>
+                  <a:srgbClr val="FFFFFF"/>
+                </a:solidFill>
+                <a:latin typeface="Calibri"/>
+              </a:defRPr>
+            </a:pPr>
+            <a:r>
+              <a:t>Paste playlist/video links to populate lectures</a:t>
+            </a:r>
+          </a:p>
+        </p:txBody>
+      </p:sp>
+      <p:sp>
+        <p:nvSpPr>
+          <p:cNvPr id="6" name="Rounded Rectangle 5"/>
+          <p:cNvSpPr/>
+          <p:nvPr/>
+        </p:nvSpPr>
+        <p:spPr>
+          <a:xfrm>
+            <a:off x="8046720" y="1828800"/>
+            <a:ext cx="3291840" cy="1645920"/>
+          </a:xfrm>
+          <a:prstGeom prst="roundRect">
+            <a:avLst/>
+          </a:prstGeom>
+          <a:solidFill>
+            <a:srgbClr val="2D2D2D"/>
+          </a:solidFill>
+          <a:ln w="19050">
+            <a:solidFill>
+              <a:srgbClr val="505050"/>
+            </a:solidFill>
+          </a:ln>
+        </p:spPr>
+        <p:style>
+          <a:lnRef idx="1">
+            <a:schemeClr val="accent1"/>
+          </a:lnRef>
+          <a:fillRef idx="3">
+            <a:schemeClr val="accent1"/>
+          </a:fillRef>
+          <a:effectRef idx="2">
+            <a:schemeClr val="accent1"/>
+          </a:effectRef>
+          <a:fontRef idx="minor">
+            <a:schemeClr val="lt1"/>
+          </a:fontRef>
+        </p:style>
+        <p:txBody>
+          <a:bodyPr rtlCol="0" anchor="ctr" wrap="square" lIns="137160" tIns="137160" rIns="137160" bIns="137160"/>
+          <a:lstStyle/>
+          <a:p>
+            <a:pPr algn="ctr">
+              <a:spcAft>
+                <a:spcPts val="800"/>
+              </a:spcAft>
+              <a:defRPr sz="1600" b="1">
+                <a:solidFill>
+                  <a:srgbClr val="81D4FA"/>
+                </a:solidFill>
+                <a:latin typeface="Calibri"/>
+              </a:defRPr>
+            </a:pPr>
+            <a:r>
+              <a:t>3. Generate Plan</a:t>
+            </a:r>
+          </a:p>
+          <a:p>
+            <a:pPr>
+              <a:spcAft>
+                <a:spcPts val="400"/>
+              </a:spcAft>
+              <a:defRPr sz="1300">
+                <a:solidFill>
+                  <a:srgbClr val="FFFFFF"/>
+                </a:solidFill>
+                <a:latin typeface="Calibri"/>
+              </a:defRPr>
+            </a:pPr>
+            <a:r>
+              <a:t>Set hours/day or total days to build schedule</a:t>
+            </a:r>
+          </a:p>
+        </p:txBody>
+      </p:sp>
+      <p:sp>
+        <p:nvSpPr>
+          <p:cNvPr id="7" name="Rounded Rectangle 6"/>
+          <p:cNvSpPr/>
+          <p:nvPr/>
+        </p:nvSpPr>
+        <p:spPr>
+          <a:xfrm>
+            <a:off x="731520" y="3840480"/>
+            <a:ext cx="3291840" cy="1645920"/>
+          </a:xfrm>
+          <a:prstGeom prst="roundRect">
+            <a:avLst/>
+          </a:prstGeom>
+          <a:solidFill>
+            <a:srgbClr val="2D2D2D"/>
+          </a:solidFill>
+          <a:ln w="19050">
+            <a:solidFill>
+              <a:srgbClr val="505050"/>
+            </a:solidFill>
+          </a:ln>
+        </p:spPr>
+        <p:style>
+          <a:lnRef idx="1">
+            <a:schemeClr val="accent1"/>
+          </a:lnRef>
+          <a:fillRef idx="3">
+            <a:schemeClr val="accent1"/>
+          </a:fillRef>
+          <a:effectRef idx="2">
+            <a:schemeClr val="accent1"/>
+          </a:effectRef>
+          <a:fontRef idx="minor">
+            <a:schemeClr val="lt1"/>
+          </a:fontRef>
+        </p:style>
+        <p:txBody>
+          <a:bodyPr rtlCol="0" anchor="ctr" wrap="square" lIns="137160" tIns="137160" rIns="137160" bIns="137160"/>
+          <a:lstStyle/>
+          <a:p>
+            <a:pPr algn="ctr">
+              <a:spcAft>
+                <a:spcPts val="800"/>
+              </a:spcAft>
+              <a:defRPr sz="1600" b="1">
+                <a:solidFill>
+                  <a:srgbClr val="F48FB1"/>
+                </a:solidFill>
+                <a:latin typeface="Calibri"/>
+              </a:defRPr>
+            </a:pPr>
+            <a:r>
+              <a:t>4. Play &amp; Bookmark</a:t>
+            </a:r>
+          </a:p>
+          <a:p>
+            <a:pPr>
+              <a:spcAft>
+                <a:spcPts val="400"/>
+              </a:spcAft>
+              <a:defRPr sz="1300">
+                <a:solidFill>
+                  <a:srgbClr val="FFFFFF"/>
+                </a:solidFill>
+                <a:latin typeface="Calibri"/>
+              </a:defRPr>
+            </a:pPr>
+            <a:r>
+              <a:t>Watch video, capture timestamped notes</a:t>
+            </a:r>
+          </a:p>
+        </p:txBody>
+      </p:sp>
+      <p:sp>
+        <p:nvSpPr>
+          <p:cNvPr id="8" name="Rounded Rectangle 7"/>
+          <p:cNvSpPr/>
+          <p:nvPr/>
+        </p:nvSpPr>
+        <p:spPr>
+          <a:xfrm>
+            <a:off x="4389120" y="3840480"/>
+            <a:ext cx="3291840" cy="1645920"/>
+          </a:xfrm>
+          <a:prstGeom prst="roundRect">
+            <a:avLst/>
+          </a:prstGeom>
+          <a:solidFill>
+            <a:srgbClr val="2D2D2D"/>
+          </a:solidFill>
+          <a:ln w="19050">
+            <a:solidFill>
+              <a:srgbClr val="505050"/>
+            </a:solidFill>
+          </a:ln>
+        </p:spPr>
+        <p:style>
+          <a:lnRef idx="1">
+            <a:schemeClr val="accent1"/>
+          </a:lnRef>
+          <a:fillRef idx="3">
+            <a:schemeClr val="accent1"/>
+          </a:fillRef>
+          <a:effectRef idx="2">
+            <a:schemeClr val="accent1"/>
+          </a:effectRef>
+          <a:fontRef idx="minor">
+            <a:schemeClr val="lt1"/>
+          </a:fontRef>
+        </p:style>
+        <p:txBody>
+          <a:bodyPr rtlCol="0" anchor="ctr" wrap="square" lIns="137160" tIns="137160" rIns="137160" bIns="137160"/>
+          <a:lstStyle/>
+          <a:p>
+            <a:pPr algn="ctr">
+              <a:spcAft>
+                <a:spcPts val="800"/>
+              </a:spcAft>
+              <a:defRPr sz="1600" b="1">
+                <a:solidFill>
+                  <a:srgbClr val="F48FB1"/>
+                </a:solidFill>
+                <a:latin typeface="Calibri"/>
+              </a:defRPr>
+            </a:pPr>
+            <a:r>
+              <a:t>5. Check Off Tasks</a:t>
+            </a:r>
+          </a:p>
+          <a:p>
+            <a:pPr>
+              <a:spcAft>
+                <a:spcPts val="400"/>
+              </a:spcAft>
+              <a:defRPr sz="1300">
+                <a:solidFill>
+                  <a:srgbClr val="FFFFFF"/>
+                </a:solidFill>
+                <a:latin typeface="Calibri"/>
+              </a:defRPr>
+            </a:pPr>
+            <a:r>
+              <a:t>Log completion, auto-update progress chart</a:t>
+            </a:r>
+          </a:p>
+        </p:txBody>
+      </p:sp>
+      <p:sp>
+        <p:nvSpPr>
+          <p:cNvPr id="9" name="Rounded Rectangle 8"/>
+          <p:cNvSpPr/>
+          <p:nvPr/>
+        </p:nvSpPr>
+        <p:spPr>
+          <a:xfrm>
+            <a:off x="8046720" y="3840480"/>
+            <a:ext cx="3291840" cy="1645920"/>
+          </a:xfrm>
+          <a:prstGeom prst="roundRect">
+            <a:avLst/>
+          </a:prstGeom>
+          <a:solidFill>
+            <a:srgbClr val="2D2D2D"/>
+          </a:solidFill>
+          <a:ln w="19050">
+            <a:solidFill>
+              <a:srgbClr val="505050"/>
+            </a:solidFill>
+          </a:ln>
+        </p:spPr>
+        <p:style>
+          <a:lnRef idx="1">
+            <a:schemeClr val="accent1"/>
+          </a:lnRef>
+          <a:fillRef idx="3">
+            <a:schemeClr val="accent1"/>
+          </a:fillRef>
+          <a:effectRef idx="2">
+            <a:schemeClr val="accent1"/>
+          </a:effectRef>
+          <a:fontRef idx="minor">
+            <a:schemeClr val="lt1"/>
+          </a:fontRef>
+        </p:style>
+        <p:txBody>
+          <a:bodyPr rtlCol="0" anchor="ctr" wrap="square" lIns="137160" tIns="137160" rIns="137160" bIns="137160"/>
+          <a:lstStyle/>
+          <a:p>
+            <a:pPr algn="ctr">
+              <a:spcAft>
+                <a:spcPts val="800"/>
+              </a:spcAft>
+              <a:defRPr sz="1600" b="1">
+                <a:solidFill>
+                  <a:srgbClr val="F48FB1"/>
+                </a:solidFill>
+                <a:latin typeface="Calibri"/>
+              </a:defRPr>
+            </a:pPr>
+            <a:r>
+              <a:t>6. Calibration</a:t>
+            </a:r>
+          </a:p>
+          <a:p>
+            <a:pPr>
+              <a:spcAft>
+                <a:spcPts val="400"/>
+              </a:spcAft>
+              <a:defRPr sz="1300">
+                <a:solidFill>
+                  <a:srgbClr val="FFFFFF"/>
+                </a:solidFill>
+                <a:latin typeface="Calibri"/>
+              </a:defRPr>
+            </a:pPr>
+            <a:r>
+              <a:t>Pause subject, resume, or adjust schedule</a:t>
             </a:r>
           </a:p>
         </p:txBody>

</xml_diff>

<commit_message>
perf: add DNS pre-fetching for YouTube and ytimaging CDN to speed up embedded video load times
</commit_message>
<xml_diff>
--- a/study_tracker_presentation.pptx
+++ b/study_tracker_presentation.pptx
@@ -5,16 +5,16 @@
     <p:sldMasterId id="2147483648" r:id="rId1"/>
   </p:sldMasterIdLst>
   <p:sldIdLst>
-    <p:sldId id="256" r:id="rId7"/>
-    <p:sldId id="257" r:id="rId8"/>
-    <p:sldId id="258" r:id="rId9"/>
-    <p:sldId id="259" r:id="rId10"/>
-    <p:sldId id="260" r:id="rId11"/>
-    <p:sldId id="261" r:id="rId12"/>
-    <p:sldId id="262" r:id="rId13"/>
-    <p:sldId id="263" r:id="rId14"/>
+    <p:sldId id="256" r:id="rId2"/>
+    <p:sldId id="257" r:id="rId3"/>
+    <p:sldId id="258" r:id="rId4"/>
+    <p:sldId id="259" r:id="rId5"/>
+    <p:sldId id="260" r:id="rId6"/>
+    <p:sldId id="261" r:id="rId7"/>
+    <p:sldId id="262" r:id="rId8"/>
+    <p:sldId id="263" r:id="rId9"/>
   </p:sldIdLst>
-  <p:sldSz cx="12191695" cy="6858000" type="screen4x3"/>
+  <p:sldSz cx="12192000" cy="6858000"/>
   <p:notesSz cx="6858000" cy="9144000"/>
   <p:defaultTextStyle>
     <a:defPPr>
@@ -111,6 +111,22 @@
       </a:defRPr>
     </a:lvl9pPr>
   </p:defaultTextStyle>
+  <p:extLst>
+    <p:ext uri="{EFAFB233-063F-42B5-8137-9DF3F51BA10A}">
+      <p15:sldGuideLst xmlns:p15="http://schemas.microsoft.com/office/powerpoint/2012/main">
+        <p15:guide id="1" orient="horz" pos="2160">
+          <p15:clr>
+            <a:srgbClr val="A4A3A4"/>
+          </p15:clr>
+        </p15:guide>
+        <p15:guide id="2" pos="2880">
+          <p15:clr>
+            <a:srgbClr val="A4A3A4"/>
+          </p15:clr>
+        </p15:guide>
+      </p15:sldGuideLst>
+    </p:ext>
+  </p:extLst>
 </p:presentation>
 </file>
 
@@ -152,10 +168,9 @@
           <a:lstStyle/>
           <a:p>
             <a:r>
-              <a:rPr lang="en-US" smtClean="0"/>
+              <a:rPr lang="en-US"/>
               <a:t>Click to edit Master title style</a:t>
             </a:r>
-            <a:endParaRPr lang="en-US"/>
           </a:p>
         </p:txBody>
       </p:sp>
@@ -271,10 +286,9 @@
           </a:lstStyle>
           <a:p>
             <a:r>
-              <a:rPr lang="en-US" smtClean="0"/>
+              <a:rPr lang="en-US"/>
               <a:t>Click to edit Master subtitle style</a:t>
             </a:r>
-            <a:endParaRPr lang="en-US"/>
           </a:p>
         </p:txBody>
       </p:sp>
@@ -295,7 +309,7 @@
           <a:p>
             <a:fld id="{5BCAD085-E8A6-8845-BD4E-CB4CCA059FC4}" type="datetimeFigureOut">
               <a:rPr lang="en-US" smtClean="0"/>
-              <a:t>1/27/13</a:t>
+              <a:t>7/17/2026</a:t>
             </a:fld>
             <a:endParaRPr lang="en-US"/>
           </a:p>
@@ -389,10 +403,9 @@
           <a:lstStyle/>
           <a:p>
             <a:r>
-              <a:rPr lang="en-US" smtClean="0"/>
+              <a:rPr lang="en-US"/>
               <a:t>Click to edit Master title style</a:t>
             </a:r>
-            <a:endParaRPr lang="en-US"/>
           </a:p>
         </p:txBody>
       </p:sp>
@@ -413,38 +426,37 @@
           <a:p>
             <a:pPr lvl="0"/>
             <a:r>
-              <a:rPr lang="en-US" smtClean="0"/>
+              <a:rPr lang="en-US"/>
               <a:t>Click to edit Master text styles</a:t>
             </a:r>
           </a:p>
           <a:p>
             <a:pPr lvl="1"/>
             <a:r>
-              <a:rPr lang="en-US" smtClean="0"/>
+              <a:rPr lang="en-US"/>
               <a:t>Second level</a:t>
             </a:r>
           </a:p>
           <a:p>
             <a:pPr lvl="2"/>
             <a:r>
-              <a:rPr lang="en-US" smtClean="0"/>
+              <a:rPr lang="en-US"/>
               <a:t>Third level</a:t>
             </a:r>
           </a:p>
           <a:p>
             <a:pPr lvl="3"/>
             <a:r>
-              <a:rPr lang="en-US" smtClean="0"/>
+              <a:rPr lang="en-US"/>
               <a:t>Fourth level</a:t>
             </a:r>
           </a:p>
           <a:p>
             <a:pPr lvl="4"/>
             <a:r>
-              <a:rPr lang="en-US" smtClean="0"/>
+              <a:rPr lang="en-US"/>
               <a:t>Fifth level</a:t>
             </a:r>
-            <a:endParaRPr lang="en-US"/>
           </a:p>
         </p:txBody>
       </p:sp>
@@ -465,7 +477,7 @@
           <a:p>
             <a:fld id="{5BCAD085-E8A6-8845-BD4E-CB4CCA059FC4}" type="datetimeFigureOut">
               <a:rPr lang="en-US" smtClean="0"/>
-              <a:t>1/27/13</a:t>
+              <a:t>7/17/2026</a:t>
             </a:fld>
             <a:endParaRPr lang="en-US"/>
           </a:p>
@@ -564,10 +576,9 @@
           <a:lstStyle/>
           <a:p>
             <a:r>
-              <a:rPr lang="en-US" smtClean="0"/>
+              <a:rPr lang="en-US"/>
               <a:t>Click to edit Master title style</a:t>
             </a:r>
-            <a:endParaRPr lang="en-US"/>
           </a:p>
         </p:txBody>
       </p:sp>
@@ -593,38 +604,37 @@
           <a:p>
             <a:pPr lvl="0"/>
             <a:r>
-              <a:rPr lang="en-US" smtClean="0"/>
+              <a:rPr lang="en-US"/>
               <a:t>Click to edit Master text styles</a:t>
             </a:r>
           </a:p>
           <a:p>
             <a:pPr lvl="1"/>
             <a:r>
-              <a:rPr lang="en-US" smtClean="0"/>
+              <a:rPr lang="en-US"/>
               <a:t>Second level</a:t>
             </a:r>
           </a:p>
           <a:p>
             <a:pPr lvl="2"/>
             <a:r>
-              <a:rPr lang="en-US" smtClean="0"/>
+              <a:rPr lang="en-US"/>
               <a:t>Third level</a:t>
             </a:r>
           </a:p>
           <a:p>
             <a:pPr lvl="3"/>
             <a:r>
-              <a:rPr lang="en-US" smtClean="0"/>
+              <a:rPr lang="en-US"/>
               <a:t>Fourth level</a:t>
             </a:r>
           </a:p>
           <a:p>
             <a:pPr lvl="4"/>
             <a:r>
-              <a:rPr lang="en-US" smtClean="0"/>
+              <a:rPr lang="en-US"/>
               <a:t>Fifth level</a:t>
             </a:r>
-            <a:endParaRPr lang="en-US"/>
           </a:p>
         </p:txBody>
       </p:sp>
@@ -645,7 +655,7 @@
           <a:p>
             <a:fld id="{5BCAD085-E8A6-8845-BD4E-CB4CCA059FC4}" type="datetimeFigureOut">
               <a:rPr lang="en-US" smtClean="0"/>
-              <a:t>1/27/13</a:t>
+              <a:t>7/17/2026</a:t>
             </a:fld>
             <a:endParaRPr lang="en-US"/>
           </a:p>
@@ -739,10 +749,9 @@
           <a:lstStyle/>
           <a:p>
             <a:r>
-              <a:rPr lang="en-US" smtClean="0"/>
+              <a:rPr lang="en-US"/>
               <a:t>Click to edit Master title style</a:t>
             </a:r>
-            <a:endParaRPr lang="en-US"/>
           </a:p>
         </p:txBody>
       </p:sp>
@@ -763,38 +772,37 @@
           <a:p>
             <a:pPr lvl="0"/>
             <a:r>
-              <a:rPr lang="en-US" smtClean="0"/>
+              <a:rPr lang="en-US"/>
               <a:t>Click to edit Master text styles</a:t>
             </a:r>
           </a:p>
           <a:p>
             <a:pPr lvl="1"/>
             <a:r>
-              <a:rPr lang="en-US" smtClean="0"/>
+              <a:rPr lang="en-US"/>
               <a:t>Second level</a:t>
             </a:r>
           </a:p>
           <a:p>
             <a:pPr lvl="2"/>
             <a:r>
-              <a:rPr lang="en-US" smtClean="0"/>
+              <a:rPr lang="en-US"/>
               <a:t>Third level</a:t>
             </a:r>
           </a:p>
           <a:p>
             <a:pPr lvl="3"/>
             <a:r>
-              <a:rPr lang="en-US" smtClean="0"/>
+              <a:rPr lang="en-US"/>
               <a:t>Fourth level</a:t>
             </a:r>
           </a:p>
           <a:p>
             <a:pPr lvl="4"/>
             <a:r>
-              <a:rPr lang="en-US" smtClean="0"/>
+              <a:rPr lang="en-US"/>
               <a:t>Fifth level</a:t>
             </a:r>
-            <a:endParaRPr lang="en-US"/>
           </a:p>
         </p:txBody>
       </p:sp>
@@ -815,7 +823,7 @@
           <a:p>
             <a:fld id="{5BCAD085-E8A6-8845-BD4E-CB4CCA059FC4}" type="datetimeFigureOut">
               <a:rPr lang="en-US" smtClean="0"/>
-              <a:t>1/27/13</a:t>
+              <a:t>7/17/2026</a:t>
             </a:fld>
             <a:endParaRPr lang="en-US"/>
           </a:p>
@@ -918,10 +926,9 @@
           </a:lstStyle>
           <a:p>
             <a:r>
-              <a:rPr lang="en-US" smtClean="0"/>
+              <a:rPr lang="en-US"/>
               <a:t>Click to edit Master title style</a:t>
             </a:r>
-            <a:endParaRPr lang="en-US"/>
           </a:p>
         </p:txBody>
       </p:sp>
@@ -1038,7 +1045,7 @@
           <a:p>
             <a:pPr lvl="0"/>
             <a:r>
-              <a:rPr lang="en-US" smtClean="0"/>
+              <a:rPr lang="en-US"/>
               <a:t>Click to edit Master text styles</a:t>
             </a:r>
           </a:p>
@@ -1061,7 +1068,7 @@
           <a:p>
             <a:fld id="{5BCAD085-E8A6-8845-BD4E-CB4CCA059FC4}" type="datetimeFigureOut">
               <a:rPr lang="en-US" smtClean="0"/>
-              <a:t>1/27/13</a:t>
+              <a:t>7/17/2026</a:t>
             </a:fld>
             <a:endParaRPr lang="en-US"/>
           </a:p>
@@ -1155,10 +1162,9 @@
           <a:lstStyle/>
           <a:p>
             <a:r>
-              <a:rPr lang="en-US" smtClean="0"/>
+              <a:rPr lang="en-US"/>
               <a:t>Click to edit Master title style</a:t>
             </a:r>
-            <a:endParaRPr lang="en-US"/>
           </a:p>
         </p:txBody>
       </p:sp>
@@ -1212,38 +1218,37 @@
           <a:p>
             <a:pPr lvl="0"/>
             <a:r>
-              <a:rPr lang="en-US" smtClean="0"/>
+              <a:rPr lang="en-US"/>
               <a:t>Click to edit Master text styles</a:t>
             </a:r>
           </a:p>
           <a:p>
             <a:pPr lvl="1"/>
             <a:r>
-              <a:rPr lang="en-US" smtClean="0"/>
+              <a:rPr lang="en-US"/>
               <a:t>Second level</a:t>
             </a:r>
           </a:p>
           <a:p>
             <a:pPr lvl="2"/>
             <a:r>
-              <a:rPr lang="en-US" smtClean="0"/>
+              <a:rPr lang="en-US"/>
               <a:t>Third level</a:t>
             </a:r>
           </a:p>
           <a:p>
             <a:pPr lvl="3"/>
             <a:r>
-              <a:rPr lang="en-US" smtClean="0"/>
+              <a:rPr lang="en-US"/>
               <a:t>Fourth level</a:t>
             </a:r>
           </a:p>
           <a:p>
             <a:pPr lvl="4"/>
             <a:r>
-              <a:rPr lang="en-US" smtClean="0"/>
+              <a:rPr lang="en-US"/>
               <a:t>Fifth level</a:t>
             </a:r>
-            <a:endParaRPr lang="en-US"/>
           </a:p>
         </p:txBody>
       </p:sp>
@@ -1297,38 +1302,37 @@
           <a:p>
             <a:pPr lvl="0"/>
             <a:r>
-              <a:rPr lang="en-US" smtClean="0"/>
+              <a:rPr lang="en-US"/>
               <a:t>Click to edit Master text styles</a:t>
             </a:r>
           </a:p>
           <a:p>
             <a:pPr lvl="1"/>
             <a:r>
-              <a:rPr lang="en-US" smtClean="0"/>
+              <a:rPr lang="en-US"/>
               <a:t>Second level</a:t>
             </a:r>
           </a:p>
           <a:p>
             <a:pPr lvl="2"/>
             <a:r>
-              <a:rPr lang="en-US" smtClean="0"/>
+              <a:rPr lang="en-US"/>
               <a:t>Third level</a:t>
             </a:r>
           </a:p>
           <a:p>
             <a:pPr lvl="3"/>
             <a:r>
-              <a:rPr lang="en-US" smtClean="0"/>
+              <a:rPr lang="en-US"/>
               <a:t>Fourth level</a:t>
             </a:r>
           </a:p>
           <a:p>
             <a:pPr lvl="4"/>
             <a:r>
-              <a:rPr lang="en-US" smtClean="0"/>
+              <a:rPr lang="en-US"/>
               <a:t>Fifth level</a:t>
             </a:r>
-            <a:endParaRPr lang="en-US"/>
           </a:p>
         </p:txBody>
       </p:sp>
@@ -1349,7 +1353,7 @@
           <a:p>
             <a:fld id="{5BCAD085-E8A6-8845-BD4E-CB4CCA059FC4}" type="datetimeFigureOut">
               <a:rPr lang="en-US" smtClean="0"/>
-              <a:t>1/27/13</a:t>
+              <a:t>7/17/2026</a:t>
             </a:fld>
             <a:endParaRPr lang="en-US"/>
           </a:p>
@@ -1447,10 +1451,9 @@
           </a:lstStyle>
           <a:p>
             <a:r>
-              <a:rPr lang="en-US" smtClean="0"/>
+              <a:rPr lang="en-US"/>
               <a:t>Click to edit Master title style</a:t>
             </a:r>
-            <a:endParaRPr lang="en-US"/>
           </a:p>
         </p:txBody>
       </p:sp>
@@ -1513,7 +1516,7 @@
           <a:p>
             <a:pPr lvl="0"/>
             <a:r>
-              <a:rPr lang="en-US" smtClean="0"/>
+              <a:rPr lang="en-US"/>
               <a:t>Click to edit Master text styles</a:t>
             </a:r>
           </a:p>
@@ -1569,38 +1572,37 @@
           <a:p>
             <a:pPr lvl="0"/>
             <a:r>
-              <a:rPr lang="en-US" smtClean="0"/>
+              <a:rPr lang="en-US"/>
               <a:t>Click to edit Master text styles</a:t>
             </a:r>
           </a:p>
           <a:p>
             <a:pPr lvl="1"/>
             <a:r>
-              <a:rPr lang="en-US" smtClean="0"/>
+              <a:rPr lang="en-US"/>
               <a:t>Second level</a:t>
             </a:r>
           </a:p>
           <a:p>
             <a:pPr lvl="2"/>
             <a:r>
-              <a:rPr lang="en-US" smtClean="0"/>
+              <a:rPr lang="en-US"/>
               <a:t>Third level</a:t>
             </a:r>
           </a:p>
           <a:p>
             <a:pPr lvl="3"/>
             <a:r>
-              <a:rPr lang="en-US" smtClean="0"/>
+              <a:rPr lang="en-US"/>
               <a:t>Fourth level</a:t>
             </a:r>
           </a:p>
           <a:p>
             <a:pPr lvl="4"/>
             <a:r>
-              <a:rPr lang="en-US" smtClean="0"/>
+              <a:rPr lang="en-US"/>
               <a:t>Fifth level</a:t>
             </a:r>
-            <a:endParaRPr lang="en-US"/>
           </a:p>
         </p:txBody>
       </p:sp>
@@ -1663,7 +1665,7 @@
           <a:p>
             <a:pPr lvl="0"/>
             <a:r>
-              <a:rPr lang="en-US" smtClean="0"/>
+              <a:rPr lang="en-US"/>
               <a:t>Click to edit Master text styles</a:t>
             </a:r>
           </a:p>
@@ -1719,38 +1721,37 @@
           <a:p>
             <a:pPr lvl="0"/>
             <a:r>
-              <a:rPr lang="en-US" smtClean="0"/>
+              <a:rPr lang="en-US"/>
               <a:t>Click to edit Master text styles</a:t>
             </a:r>
           </a:p>
           <a:p>
             <a:pPr lvl="1"/>
             <a:r>
-              <a:rPr lang="en-US" smtClean="0"/>
+              <a:rPr lang="en-US"/>
               <a:t>Second level</a:t>
             </a:r>
           </a:p>
           <a:p>
             <a:pPr lvl="2"/>
             <a:r>
-              <a:rPr lang="en-US" smtClean="0"/>
+              <a:rPr lang="en-US"/>
               <a:t>Third level</a:t>
             </a:r>
           </a:p>
           <a:p>
             <a:pPr lvl="3"/>
             <a:r>
-              <a:rPr lang="en-US" smtClean="0"/>
+              <a:rPr lang="en-US"/>
               <a:t>Fourth level</a:t>
             </a:r>
           </a:p>
           <a:p>
             <a:pPr lvl="4"/>
             <a:r>
-              <a:rPr lang="en-US" smtClean="0"/>
+              <a:rPr lang="en-US"/>
               <a:t>Fifth level</a:t>
             </a:r>
-            <a:endParaRPr lang="en-US"/>
           </a:p>
         </p:txBody>
       </p:sp>
@@ -1771,7 +1772,7 @@
           <a:p>
             <a:fld id="{5BCAD085-E8A6-8845-BD4E-CB4CCA059FC4}" type="datetimeFigureOut">
               <a:rPr lang="en-US" smtClean="0"/>
-              <a:t>1/27/13</a:t>
+              <a:t>7/17/2026</a:t>
             </a:fld>
             <a:endParaRPr lang="en-US"/>
           </a:p>
@@ -1865,10 +1866,9 @@
           <a:lstStyle/>
           <a:p>
             <a:r>
-              <a:rPr lang="en-US" smtClean="0"/>
+              <a:rPr lang="en-US"/>
               <a:t>Click to edit Master title style</a:t>
             </a:r>
-            <a:endParaRPr lang="en-US"/>
           </a:p>
         </p:txBody>
       </p:sp>
@@ -1889,7 +1889,7 @@
           <a:p>
             <a:fld id="{5BCAD085-E8A6-8845-BD4E-CB4CCA059FC4}" type="datetimeFigureOut">
               <a:rPr lang="en-US" smtClean="0"/>
-              <a:t>1/27/13</a:t>
+              <a:t>7/17/2026</a:t>
             </a:fld>
             <a:endParaRPr lang="en-US"/>
           </a:p>
@@ -1984,7 +1984,7 @@
           <a:p>
             <a:fld id="{5BCAD085-E8A6-8845-BD4E-CB4CCA059FC4}" type="datetimeFigureOut">
               <a:rPr lang="en-US" smtClean="0"/>
-              <a:t>1/27/13</a:t>
+              <a:t>7/17/2026</a:t>
             </a:fld>
             <a:endParaRPr lang="en-US"/>
           </a:p>
@@ -2087,10 +2087,9 @@
           </a:lstStyle>
           <a:p>
             <a:r>
-              <a:rPr lang="en-US" smtClean="0"/>
+              <a:rPr lang="en-US"/>
               <a:t>Click to edit Master title style</a:t>
             </a:r>
-            <a:endParaRPr lang="en-US"/>
           </a:p>
         </p:txBody>
       </p:sp>
@@ -2144,38 +2143,37 @@
           <a:p>
             <a:pPr lvl="0"/>
             <a:r>
-              <a:rPr lang="en-US" smtClean="0"/>
+              <a:rPr lang="en-US"/>
               <a:t>Click to edit Master text styles</a:t>
             </a:r>
           </a:p>
           <a:p>
             <a:pPr lvl="1"/>
             <a:r>
-              <a:rPr lang="en-US" smtClean="0"/>
+              <a:rPr lang="en-US"/>
               <a:t>Second level</a:t>
             </a:r>
           </a:p>
           <a:p>
             <a:pPr lvl="2"/>
             <a:r>
-              <a:rPr lang="en-US" smtClean="0"/>
+              <a:rPr lang="en-US"/>
               <a:t>Third level</a:t>
             </a:r>
           </a:p>
           <a:p>
             <a:pPr lvl="3"/>
             <a:r>
-              <a:rPr lang="en-US" smtClean="0"/>
+              <a:rPr lang="en-US"/>
               <a:t>Fourth level</a:t>
             </a:r>
           </a:p>
           <a:p>
             <a:pPr lvl="4"/>
             <a:r>
-              <a:rPr lang="en-US" smtClean="0"/>
+              <a:rPr lang="en-US"/>
               <a:t>Fifth level</a:t>
             </a:r>
-            <a:endParaRPr lang="en-US"/>
           </a:p>
         </p:txBody>
       </p:sp>
@@ -2238,7 +2236,7 @@
           <a:p>
             <a:pPr lvl="0"/>
             <a:r>
-              <a:rPr lang="en-US" smtClean="0"/>
+              <a:rPr lang="en-US"/>
               <a:t>Click to edit Master text styles</a:t>
             </a:r>
           </a:p>
@@ -2261,7 +2259,7 @@
           <a:p>
             <a:fld id="{5BCAD085-E8A6-8845-BD4E-CB4CCA059FC4}" type="datetimeFigureOut">
               <a:rPr lang="en-US" smtClean="0"/>
-              <a:t>1/27/13</a:t>
+              <a:t>7/17/2026</a:t>
             </a:fld>
             <a:endParaRPr lang="en-US"/>
           </a:p>
@@ -2364,10 +2362,9 @@
           </a:lstStyle>
           <a:p>
             <a:r>
-              <a:rPr lang="en-US" smtClean="0"/>
+              <a:rPr lang="en-US"/>
               <a:t>Click to edit Master title style</a:t>
             </a:r>
-            <a:endParaRPr lang="en-US"/>
           </a:p>
         </p:txBody>
       </p:sp>
@@ -2491,7 +2488,7 @@
           <a:p>
             <a:pPr lvl="0"/>
             <a:r>
-              <a:rPr lang="en-US" smtClean="0"/>
+              <a:rPr lang="en-US"/>
               <a:t>Click to edit Master text styles</a:t>
             </a:r>
           </a:p>
@@ -2514,7 +2511,7 @@
           <a:p>
             <a:fld id="{5BCAD085-E8A6-8845-BD4E-CB4CCA059FC4}" type="datetimeFigureOut">
               <a:rPr lang="en-US" smtClean="0"/>
-              <a:t>1/27/13</a:t>
+              <a:t>7/17/2026</a:t>
             </a:fld>
             <a:endParaRPr lang="en-US"/>
           </a:p>
@@ -2623,10 +2620,9 @@
           <a:lstStyle/>
           <a:p>
             <a:r>
-              <a:rPr lang="en-US" smtClean="0"/>
+              <a:rPr lang="en-US"/>
               <a:t>Click to edit Master title style</a:t>
             </a:r>
-            <a:endParaRPr lang="en-US"/>
           </a:p>
         </p:txBody>
       </p:sp>
@@ -2657,38 +2653,37 @@
           <a:p>
             <a:pPr lvl="0"/>
             <a:r>
-              <a:rPr lang="en-US" smtClean="0"/>
+              <a:rPr lang="en-US"/>
               <a:t>Click to edit Master text styles</a:t>
             </a:r>
           </a:p>
           <a:p>
             <a:pPr lvl="1"/>
             <a:r>
-              <a:rPr lang="en-US" smtClean="0"/>
+              <a:rPr lang="en-US"/>
               <a:t>Second level</a:t>
             </a:r>
           </a:p>
           <a:p>
             <a:pPr lvl="2"/>
             <a:r>
-              <a:rPr lang="en-US" smtClean="0"/>
+              <a:rPr lang="en-US"/>
               <a:t>Third level</a:t>
             </a:r>
           </a:p>
           <a:p>
             <a:pPr lvl="3"/>
             <a:r>
-              <a:rPr lang="en-US" smtClean="0"/>
+              <a:rPr lang="en-US"/>
               <a:t>Fourth level</a:t>
             </a:r>
           </a:p>
           <a:p>
             <a:pPr lvl="4"/>
             <a:r>
-              <a:rPr lang="en-US" smtClean="0"/>
+              <a:rPr lang="en-US"/>
               <a:t>Fifth level</a:t>
             </a:r>
-            <a:endParaRPr lang="en-US"/>
           </a:p>
         </p:txBody>
       </p:sp>
@@ -2727,7 +2722,7 @@
           <a:p>
             <a:fld id="{5BCAD085-E8A6-8845-BD4E-CB4CCA059FC4}" type="datetimeFigureOut">
               <a:rPr lang="en-US" smtClean="0"/>
-              <a:t>1/27/13</a:t>
+              <a:t>7/17/2026</a:t>
             </a:fld>
             <a:endParaRPr lang="en-US"/>
           </a:p>
@@ -3086,7 +3081,7 @@
 </file>
 
 <file path=ppt/slides/slide1.xml><?xml version="1.0" encoding="utf-8"?>
-<p:sld xmlns:a="http://schemas.openxmlformats.org/drawingml/2006/main" xmlns:p="http://schemas.openxmlformats.org/presentationml/2006/main" xmlns:r="http://schemas.openxmlformats.org/officeDocument/2006/relationships">
+<p:sld xmlns:a="http://schemas.openxmlformats.org/drawingml/2006/main" xmlns:r="http://schemas.openxmlformats.org/officeDocument/2006/relationships" xmlns:p="http://schemas.openxmlformats.org/presentationml/2006/main">
   <p:cSld>
     <p:bg>
       <p:bgPr>
@@ -3102,7 +3097,14 @@
         <p:cNvGrpSpPr/>
         <p:nvPr/>
       </p:nvGrpSpPr>
-      <p:grpSpPr/>
+      <p:grpSpPr>
+        <a:xfrm>
+          <a:off x="0" y="0"/>
+          <a:ext cx="0" cy="0"/>
+          <a:chOff x="0" y="0"/>
+          <a:chExt cx="0" cy="0"/>
+        </a:xfrm>
+      </p:grpSpPr>
       <p:sp>
         <p:nvSpPr>
           <p:cNvPr id="2" name="TextBox 1"/>
@@ -3180,7 +3182,7 @@
 </file>
 
 <file path=ppt/slides/slide2.xml><?xml version="1.0" encoding="utf-8"?>
-<p:sld xmlns:a="http://schemas.openxmlformats.org/drawingml/2006/main" xmlns:p="http://schemas.openxmlformats.org/presentationml/2006/main" xmlns:r="http://schemas.openxmlformats.org/officeDocument/2006/relationships">
+<p:sld xmlns:a="http://schemas.openxmlformats.org/drawingml/2006/main" xmlns:r="http://schemas.openxmlformats.org/officeDocument/2006/relationships" xmlns:p="http://schemas.openxmlformats.org/presentationml/2006/main">
   <p:cSld>
     <p:bg>
       <p:bgPr>
@@ -3196,7 +3198,14 @@
         <p:cNvGrpSpPr/>
         <p:nvPr/>
       </p:nvGrpSpPr>
-      <p:grpSpPr/>
+      <p:grpSpPr>
+        <a:xfrm>
+          <a:off x="0" y="0"/>
+          <a:ext cx="0" cy="0"/>
+          <a:chOff x="0" y="0"/>
+          <a:chExt cx="0" cy="0"/>
+        </a:xfrm>
+      </p:grpSpPr>
       <p:sp>
         <p:nvSpPr>
           <p:cNvPr id="2" name="TextBox 1"/>
@@ -3307,7 +3316,7 @@
           </a:fontRef>
         </p:style>
         <p:txBody>
-          <a:bodyPr rtlCol="0" anchor="ctr" wrap="square" lIns="137160" tIns="137160" rIns="137160" bIns="137160"/>
+          <a:bodyPr wrap="square" lIns="137160" tIns="137160" rIns="137160" bIns="137160" rtlCol="0" anchor="ctr"/>
           <a:lstStyle/>
           <a:p>
             <a:pPr algn="ctr">
@@ -3429,7 +3438,7 @@
           </a:fontRef>
         </p:style>
         <p:txBody>
-          <a:bodyPr rtlCol="0" anchor="ctr" wrap="square" lIns="137160" tIns="137160" rIns="137160" bIns="137160"/>
+          <a:bodyPr wrap="square" lIns="137160" tIns="137160" rIns="137160" bIns="137160" rtlCol="0" anchor="ctr"/>
           <a:lstStyle/>
           <a:p>
             <a:pPr algn="ctr">
@@ -3522,7 +3531,7 @@
 </file>
 
 <file path=ppt/slides/slide3.xml><?xml version="1.0" encoding="utf-8"?>
-<p:sld xmlns:a="http://schemas.openxmlformats.org/drawingml/2006/main" xmlns:p="http://schemas.openxmlformats.org/presentationml/2006/main" xmlns:r="http://schemas.openxmlformats.org/officeDocument/2006/relationships">
+<p:sld xmlns:a="http://schemas.openxmlformats.org/drawingml/2006/main" xmlns:r="http://schemas.openxmlformats.org/officeDocument/2006/relationships" xmlns:p="http://schemas.openxmlformats.org/presentationml/2006/main">
   <p:cSld>
     <p:bg>
       <p:bgPr>
@@ -3538,7 +3547,14 @@
         <p:cNvGrpSpPr/>
         <p:nvPr/>
       </p:nvGrpSpPr>
-      <p:grpSpPr/>
+      <p:grpSpPr>
+        <a:xfrm>
+          <a:off x="0" y="0"/>
+          <a:ext cx="0" cy="0"/>
+          <a:chOff x="0" y="0"/>
+          <a:chExt cx="0" cy="0"/>
+        </a:xfrm>
+      </p:grpSpPr>
       <p:sp>
         <p:nvSpPr>
           <p:cNvPr id="2" name="TextBox 1"/>
@@ -3649,7 +3665,7 @@
           </a:fontRef>
         </p:style>
         <p:txBody>
-          <a:bodyPr rtlCol="0" anchor="ctr" wrap="square" lIns="137160" tIns="137160" rIns="137160" bIns="137160"/>
+          <a:bodyPr wrap="square" lIns="137160" tIns="137160" rIns="137160" bIns="137160" rtlCol="0" anchor="ctr"/>
           <a:lstStyle/>
           <a:p>
             <a:pPr algn="ctr">
@@ -3819,7 +3835,7 @@
           </a:fontRef>
         </p:style>
         <p:txBody>
-          <a:bodyPr rtlCol="0" anchor="ctr" wrap="square" lIns="137160" tIns="137160" rIns="137160" bIns="137160"/>
+          <a:bodyPr wrap="square" lIns="137160" tIns="137160" rIns="137160" bIns="137160" rtlCol="0" anchor="ctr"/>
           <a:lstStyle/>
           <a:p>
             <a:pPr algn="ctr">
@@ -4005,7 +4021,7 @@
           </a:fontRef>
         </p:style>
         <p:txBody>
-          <a:bodyPr rtlCol="0" anchor="ctr" wrap="square" lIns="137160" tIns="137160" rIns="137160" bIns="137160"/>
+          <a:bodyPr wrap="square" lIns="137160" tIns="137160" rIns="137160" bIns="137160" rtlCol="0" anchor="ctr"/>
           <a:lstStyle/>
           <a:p>
             <a:pPr algn="ctr">
@@ -4127,7 +4143,7 @@
           </a:fontRef>
         </p:style>
         <p:txBody>
-          <a:bodyPr rtlCol="0" anchor="ctr" wrap="square" lIns="137160" tIns="137160" rIns="137160" bIns="137160"/>
+          <a:bodyPr wrap="square" lIns="137160" tIns="137160" rIns="137160" bIns="137160" rtlCol="0" anchor="ctr"/>
           <a:lstStyle/>
           <a:p>
             <a:pPr algn="ctr">
@@ -4265,7 +4281,7 @@
           </a:fontRef>
         </p:style>
         <p:txBody>
-          <a:bodyPr rtlCol="0" anchor="ctr" wrap="square" lIns="137160" tIns="137160" rIns="137160" bIns="137160"/>
+          <a:bodyPr wrap="square" lIns="137160" tIns="137160" rIns="137160" bIns="137160" rtlCol="0" anchor="ctr"/>
           <a:lstStyle/>
           <a:p>
             <a:pPr algn="ctr">
@@ -4374,7 +4390,7 @@
 </file>
 
 <file path=ppt/slides/slide4.xml><?xml version="1.0" encoding="utf-8"?>
-<p:sld xmlns:a="http://schemas.openxmlformats.org/drawingml/2006/main" xmlns:p="http://schemas.openxmlformats.org/presentationml/2006/main" xmlns:r="http://schemas.openxmlformats.org/officeDocument/2006/relationships">
+<p:sld xmlns:a="http://schemas.openxmlformats.org/drawingml/2006/main" xmlns:r="http://schemas.openxmlformats.org/officeDocument/2006/relationships" xmlns:p="http://schemas.openxmlformats.org/presentationml/2006/main">
   <p:cSld>
     <p:bg>
       <p:bgPr>
@@ -4390,7 +4406,14 @@
         <p:cNvGrpSpPr/>
         <p:nvPr/>
       </p:nvGrpSpPr>
-      <p:grpSpPr/>
+      <p:grpSpPr>
+        <a:xfrm>
+          <a:off x="0" y="0"/>
+          <a:ext cx="0" cy="0"/>
+          <a:chOff x="0" y="0"/>
+          <a:chExt cx="0" cy="0"/>
+        </a:xfrm>
+      </p:grpSpPr>
       <p:sp>
         <p:nvSpPr>
           <p:cNvPr id="2" name="TextBox 1"/>
@@ -4501,7 +4524,7 @@
           </a:fontRef>
         </p:style>
         <p:txBody>
-          <a:bodyPr rtlCol="0" anchor="ctr" wrap="square" lIns="137160" tIns="137160" rIns="137160" bIns="137160"/>
+          <a:bodyPr wrap="square" lIns="137160" tIns="137160" rIns="137160" bIns="137160" rtlCol="0" anchor="ctr"/>
           <a:lstStyle/>
           <a:p>
             <a:pPr algn="ctr">
@@ -4687,7 +4710,7 @@
           </a:fontRef>
         </p:style>
         <p:txBody>
-          <a:bodyPr rtlCol="0" anchor="ctr" wrap="square" lIns="137160" tIns="137160" rIns="137160" bIns="137160"/>
+          <a:bodyPr wrap="square" lIns="137160" tIns="137160" rIns="137160" bIns="137160" rtlCol="0" anchor="ctr"/>
           <a:lstStyle/>
           <a:p>
             <a:pPr algn="ctr">
@@ -4780,7 +4803,7 @@
 </file>
 
 <file path=ppt/slides/slide5.xml><?xml version="1.0" encoding="utf-8"?>
-<p:sld xmlns:a="http://schemas.openxmlformats.org/drawingml/2006/main" xmlns:p="http://schemas.openxmlformats.org/presentationml/2006/main" xmlns:r="http://schemas.openxmlformats.org/officeDocument/2006/relationships">
+<p:sld xmlns:a="http://schemas.openxmlformats.org/drawingml/2006/main" xmlns:r="http://schemas.openxmlformats.org/officeDocument/2006/relationships" xmlns:p="http://schemas.openxmlformats.org/presentationml/2006/main">
   <p:cSld>
     <p:bg>
       <p:bgPr>
@@ -4796,7 +4819,14 @@
         <p:cNvGrpSpPr/>
         <p:nvPr/>
       </p:nvGrpSpPr>
-      <p:grpSpPr/>
+      <p:grpSpPr>
+        <a:xfrm>
+          <a:off x="0" y="0"/>
+          <a:ext cx="0" cy="0"/>
+          <a:chOff x="0" y="0"/>
+          <a:chExt cx="0" cy="0"/>
+        </a:xfrm>
+      </p:grpSpPr>
       <p:sp>
         <p:nvSpPr>
           <p:cNvPr id="2" name="TextBox 1"/>
@@ -4907,7 +4937,7 @@
           </a:fontRef>
         </p:style>
         <p:txBody>
-          <a:bodyPr rtlCol="0" anchor="ctr" wrap="square" lIns="137160" tIns="137160" rIns="137160" bIns="137160"/>
+          <a:bodyPr wrap="square" lIns="137160" tIns="137160" rIns="137160" bIns="137160" rtlCol="0" anchor="ctr"/>
           <a:lstStyle/>
           <a:p>
             <a:pPr algn="ctr">
@@ -5061,7 +5091,7 @@
           </a:fontRef>
         </p:style>
         <p:txBody>
-          <a:bodyPr rtlCol="0" anchor="ctr" wrap="square" lIns="137160" tIns="137160" rIns="137160" bIns="137160"/>
+          <a:bodyPr wrap="square" lIns="137160" tIns="137160" rIns="137160" bIns="137160" rtlCol="0" anchor="ctr"/>
           <a:lstStyle/>
           <a:p>
             <a:pPr algn="ctr">
@@ -5186,7 +5216,7 @@
 </file>
 
 <file path=ppt/slides/slide6.xml><?xml version="1.0" encoding="utf-8"?>
-<p:sld xmlns:a="http://schemas.openxmlformats.org/drawingml/2006/main" xmlns:p="http://schemas.openxmlformats.org/presentationml/2006/main" xmlns:r="http://schemas.openxmlformats.org/officeDocument/2006/relationships">
+<p:sld xmlns:a="http://schemas.openxmlformats.org/drawingml/2006/main" xmlns:r="http://schemas.openxmlformats.org/officeDocument/2006/relationships" xmlns:p="http://schemas.openxmlformats.org/presentationml/2006/main">
   <p:cSld>
     <p:bg>
       <p:bgPr>
@@ -5202,7 +5232,14 @@
         <p:cNvGrpSpPr/>
         <p:nvPr/>
       </p:nvGrpSpPr>
-      <p:grpSpPr/>
+      <p:grpSpPr>
+        <a:xfrm>
+          <a:off x="0" y="0"/>
+          <a:ext cx="0" cy="0"/>
+          <a:chOff x="0" y="0"/>
+          <a:chExt cx="0" cy="0"/>
+        </a:xfrm>
+      </p:grpSpPr>
       <p:sp>
         <p:nvSpPr>
           <p:cNvPr id="2" name="TextBox 1"/>
@@ -5313,7 +5350,7 @@
           </a:fontRef>
         </p:style>
         <p:txBody>
-          <a:bodyPr rtlCol="0" anchor="ctr" wrap="square" lIns="137160" tIns="137160" rIns="137160" bIns="137160"/>
+          <a:bodyPr wrap="square" lIns="137160" tIns="137160" rIns="137160" bIns="137160" rtlCol="0" anchor="ctr"/>
           <a:lstStyle/>
           <a:p>
             <a:pPr algn="ctr">
@@ -5467,7 +5504,7 @@
           </a:fontRef>
         </p:style>
         <p:txBody>
-          <a:bodyPr rtlCol="0" anchor="ctr" wrap="square" lIns="137160" tIns="137160" rIns="137160" bIns="137160"/>
+          <a:bodyPr wrap="square" lIns="137160" tIns="137160" rIns="137160" bIns="137160" rtlCol="0" anchor="ctr"/>
           <a:lstStyle/>
           <a:p>
             <a:pPr algn="ctr">
@@ -5608,7 +5645,7 @@
 </file>
 
 <file path=ppt/slides/slide7.xml><?xml version="1.0" encoding="utf-8"?>
-<p:sld xmlns:a="http://schemas.openxmlformats.org/drawingml/2006/main" xmlns:p="http://schemas.openxmlformats.org/presentationml/2006/main" xmlns:r="http://schemas.openxmlformats.org/officeDocument/2006/relationships">
+<p:sld xmlns:a="http://schemas.openxmlformats.org/drawingml/2006/main" xmlns:r="http://schemas.openxmlformats.org/officeDocument/2006/relationships" xmlns:p="http://schemas.openxmlformats.org/presentationml/2006/main">
   <p:cSld>
     <p:bg>
       <p:bgPr>
@@ -5624,7 +5661,14 @@
         <p:cNvGrpSpPr/>
         <p:nvPr/>
       </p:nvGrpSpPr>
-      <p:grpSpPr/>
+      <p:grpSpPr>
+        <a:xfrm>
+          <a:off x="0" y="0"/>
+          <a:ext cx="0" cy="0"/>
+          <a:chOff x="0" y="0"/>
+          <a:chExt cx="0" cy="0"/>
+        </a:xfrm>
+      </p:grpSpPr>
       <p:sp>
         <p:nvSpPr>
           <p:cNvPr id="2" name="TextBox 1"/>
@@ -5735,7 +5779,7 @@
           </a:fontRef>
         </p:style>
         <p:txBody>
-          <a:bodyPr rtlCol="0" anchor="ctr" wrap="square" lIns="137160" tIns="137160" rIns="137160" bIns="137160"/>
+          <a:bodyPr wrap="square" lIns="137160" tIns="137160" rIns="137160" bIns="137160" rtlCol="0" anchor="ctr"/>
           <a:lstStyle/>
           <a:p>
             <a:pPr algn="ctr">
@@ -5889,7 +5933,7 @@
           </a:fontRef>
         </p:style>
         <p:txBody>
-          <a:bodyPr rtlCol="0" anchor="ctr" wrap="square" lIns="137160" tIns="137160" rIns="137160" bIns="137160"/>
+          <a:bodyPr wrap="square" lIns="137160" tIns="137160" rIns="137160" bIns="137160" rtlCol="0" anchor="ctr"/>
           <a:lstStyle/>
           <a:p>
             <a:pPr algn="ctr">
@@ -6046,7 +6090,7 @@
 </file>
 
 <file path=ppt/slides/slide8.xml><?xml version="1.0" encoding="utf-8"?>
-<p:sld xmlns:a="http://schemas.openxmlformats.org/drawingml/2006/main" xmlns:p="http://schemas.openxmlformats.org/presentationml/2006/main" xmlns:r="http://schemas.openxmlformats.org/officeDocument/2006/relationships">
+<p:sld xmlns:a="http://schemas.openxmlformats.org/drawingml/2006/main" xmlns:r="http://schemas.openxmlformats.org/officeDocument/2006/relationships" xmlns:p="http://schemas.openxmlformats.org/presentationml/2006/main">
   <p:cSld>
     <p:bg>
       <p:bgPr>
@@ -6062,7 +6106,14 @@
         <p:cNvGrpSpPr/>
         <p:nvPr/>
       </p:nvGrpSpPr>
-      <p:grpSpPr/>
+      <p:grpSpPr>
+        <a:xfrm>
+          <a:off x="0" y="0"/>
+          <a:ext cx="0" cy="0"/>
+          <a:chOff x="0" y="0"/>
+          <a:chExt cx="0" cy="0"/>
+        </a:xfrm>
+      </p:grpSpPr>
       <p:sp>
         <p:nvSpPr>
           <p:cNvPr id="2" name="TextBox 1"/>
@@ -6173,7 +6224,7 @@
           </a:fontRef>
         </p:style>
         <p:txBody>
-          <a:bodyPr rtlCol="0" anchor="ctr" wrap="square" lIns="137160" tIns="137160" rIns="137160" bIns="137160"/>
+          <a:bodyPr wrap="square" lIns="137160" tIns="137160" rIns="137160" bIns="137160" rtlCol="0" anchor="ctr"/>
           <a:lstStyle/>
           <a:p>
             <a:pPr algn="ctr">
@@ -6247,7 +6298,7 @@
           </a:fontRef>
         </p:style>
         <p:txBody>
-          <a:bodyPr rtlCol="0" anchor="ctr" wrap="square" lIns="137160" tIns="137160" rIns="137160" bIns="137160"/>
+          <a:bodyPr wrap="square" lIns="137160" tIns="137160" rIns="137160" bIns="137160" rtlCol="0" anchor="ctr"/>
           <a:lstStyle/>
           <a:p>
             <a:pPr algn="ctr">
@@ -6321,7 +6372,7 @@
           </a:fontRef>
         </p:style>
         <p:txBody>
-          <a:bodyPr rtlCol="0" anchor="ctr" wrap="square" lIns="137160" tIns="137160" rIns="137160" bIns="137160"/>
+          <a:bodyPr wrap="square" lIns="137160" tIns="137160" rIns="137160" bIns="137160" rtlCol="0" anchor="ctr"/>
           <a:lstStyle/>
           <a:p>
             <a:pPr algn="ctr">
@@ -6395,7 +6446,7 @@
           </a:fontRef>
         </p:style>
         <p:txBody>
-          <a:bodyPr rtlCol="0" anchor="ctr" wrap="square" lIns="137160" tIns="137160" rIns="137160" bIns="137160"/>
+          <a:bodyPr wrap="square" lIns="137160" tIns="137160" rIns="137160" bIns="137160" rtlCol="0" anchor="ctr"/>
           <a:lstStyle/>
           <a:p>
             <a:pPr algn="ctr">
@@ -6469,7 +6520,7 @@
           </a:fontRef>
         </p:style>
         <p:txBody>
-          <a:bodyPr rtlCol="0" anchor="ctr" wrap="square" lIns="137160" tIns="137160" rIns="137160" bIns="137160"/>
+          <a:bodyPr wrap="square" lIns="137160" tIns="137160" rIns="137160" bIns="137160" rtlCol="0" anchor="ctr"/>
           <a:lstStyle/>
           <a:p>
             <a:pPr algn="ctr">
@@ -6543,7 +6594,7 @@
           </a:fontRef>
         </p:style>
         <p:txBody>
-          <a:bodyPr rtlCol="0" anchor="ctr" wrap="square" lIns="137160" tIns="137160" rIns="137160" bIns="137160"/>
+          <a:bodyPr wrap="square" lIns="137160" tIns="137160" rIns="137160" bIns="137160" rtlCol="0" anchor="ctr"/>
           <a:lstStyle/>
           <a:p>
             <a:pPr algn="ctr">

</xml_diff>